<commit_message>
feat: add analytics dashboard with burndown, health cards, timeline & changes feed
- Created analyticsService.ts with shared analytics engine
- Added 4 API endpoints: /api/analytics/{burndown,workstream-health,timeline,changes}
- Added bot commands: 'workstream health', 'what changed today'
- Created analytics.js frontend with Chart.js burndown, CSS Gantt timeline,
  workstream health cards with color coding, and recent changes feed
- Created analytics.css with responsive grid layout
- Added Analytics tab to web UI with Corp/Fed track toggle
- Seeds daily analytics snapshots on startup

Co-authored-by: Copilot <223556219+Copilot@users.noreply.github.com>
</commit_message>
<xml_diff>
--- a/docs/QQIA-Agent-Learnings.pptx
+++ b/docs/QQIA-Agent-Learnings.pptx
@@ -4,6 +4,9 @@
   <p:sldMasterIdLst>
     <p:sldMasterId id="2147483648" r:id="rId1"/>
   </p:sldMasterIdLst>
+  <p:notesMasterIdLst>
+    <p:notesMasterId r:id="rId13"/>
+  </p:notesMasterIdLst>
   <p:sldIdLst>
     <p:sldId id="256" r:id="rId2"/>
     <p:sldId id="257" r:id="rId3"/>
@@ -17,10 +20,7 @@
     <p:sldId id="265" r:id="rId11"/>
     <p:sldId id="266" r:id="rId12"/>
   </p:sldIdLst>
-  <p:notesMasterIdLst>
-    <p:notesMasterId r:id="rId13"/>
-  </p:notesMasterIdLst>
-  <p:sldSz cx="9144000" cy="5143500"/>
+  <p:sldSz cx="9144000" cy="5143500" type="screen16x9"/>
   <p:notesSz cx="5143500" cy="9144000"/>
   <p:defaultTextStyle>
     <a:lvl1pPr marL="0" algn="l" defTabSz="914400" rtl="0" eaLnBrk="1" latinLnBrk="0" hangingPunct="1">
@@ -114,6 +114,11 @@
       </a:defRPr>
     </a:lvl9pPr>
   </p:defaultTextStyle>
+  <p:extLst>
+    <p:ext uri="{EFAFB233-063F-42B5-8137-9DF3F51BA10A}">
+      <p15:sldGuideLst xmlns:p15="http://schemas.microsoft.com/office/powerpoint/2012/main"/>
+    </p:ext>
+  </p:extLst>
 </p:presentation>
 </file>
 
@@ -139,234 +144,10 @@
           <a:chExt cx="0" cy="0"/>
         </a:xfrm>
       </p:grpSpPr>
-      <p:sp>
-        <p:nvSpPr>
-          <p:cNvPr id="2" name="Header Placeholder 1"/>
-          <p:cNvSpPr>
-            <a:spLocks noGrp="1"/>
-          </p:cNvSpPr>
-          <p:nvPr>
-            <p:ph type="hdr" sz="quarter"/>
-          </p:nvPr>
-        </p:nvSpPr>
-        <p:spPr>
-          <a:xfrm>
-            <a:off x="0" y="0"/>
-            <a:ext cx="2971800" cy="458788"/>
-          </a:xfrm>
-          <a:prstGeom prst="rect">
-            <a:avLst/>
-          </a:prstGeom>
-        </p:spPr>
-        <p:txBody>
-          <a:bodyPr vert="horz" lIns="91440" tIns="45720" rIns="91440" bIns="45720" rtlCol="0"/>
-          <a:lstStyle>
-            <a:lvl1pPr algn="l">
-              <a:defRPr sz="1200"/>
-            </a:lvl1pPr>
-          </a:lstStyle>
-          <a:p>
-            <a:endParaRPr lang="en-US"/>
-          </a:p>
-        </p:txBody>
-      </p:sp>
-      <p:sp>
-        <p:nvSpPr>
-          <p:cNvPr id="3" name="Date Placeholder 2"/>
-          <p:cNvSpPr>
-            <a:spLocks noGrp="1"/>
-          </p:cNvSpPr>
-          <p:nvPr>
-            <p:ph type="dt" idx="1"/>
-          </p:nvPr>
-        </p:nvSpPr>
-        <p:spPr>
-          <a:xfrm>
-            <a:off x="3884613" y="0"/>
-            <a:ext cx="2971800" cy="458788"/>
-          </a:xfrm>
-          <a:prstGeom prst="rect">
-            <a:avLst/>
-          </a:prstGeom>
-        </p:spPr>
-        <p:txBody>
-          <a:bodyPr vert="horz" lIns="91440" tIns="45720" rIns="91440" bIns="45720" rtlCol="0"/>
-          <a:lstStyle>
-            <a:lvl1pPr algn="r">
-              <a:defRPr sz="1200"/>
-            </a:lvl1pPr>
-          </a:lstStyle>
-          <a:p>
-            <a:fld id="{5282F153-3F37-0F45-9E97-73ACFA13230C}" type="datetimeFigureOut">
-              <a:rPr lang="en-US"/>
-              <a:t>7/23/19</a:t>
-            </a:fld>
-            <a:endParaRPr lang="en-US"/>
-          </a:p>
-        </p:txBody>
-      </p:sp>
-      <p:sp>
-        <p:nvSpPr>
-          <p:cNvPr id="4" name="Slide Image Placeholder 3"/>
-          <p:cNvSpPr>
-            <a:spLocks noGrp="1" noRot="1" noChangeAspect="1"/>
-          </p:cNvSpPr>
-          <p:nvPr>
-            <p:ph type="sldImg" idx="2"/>
-          </p:nvPr>
-        </p:nvSpPr>
-        <p:spPr>
-          <a:xfrm>
-            <a:off x="685800" y="1143000"/>
-            <a:ext cx="5486400" cy="3086100"/>
-          </a:xfrm>
-          <a:prstGeom prst="rect">
-            <a:avLst/>
-          </a:prstGeom>
-          <a:noFill/>
-          <a:ln w="12700">
-            <a:solidFill>
-              <a:prstClr val="black"/>
-            </a:solidFill>
-          </a:ln>
-        </p:spPr>
-        <p:txBody>
-          <a:bodyPr vert="horz" lIns="91440" tIns="45720" rIns="91440" bIns="45720" rtlCol="0" anchor="ctr"/>
-          <a:lstStyle/>
-          <a:p>
-            <a:endParaRPr lang="en-US"/>
-          </a:p>
-        </p:txBody>
-      </p:sp>
-      <p:sp>
-        <p:nvSpPr>
-          <p:cNvPr id="5" name="Notes Placeholder 4"/>
-          <p:cNvSpPr>
-            <a:spLocks noGrp="1"/>
-          </p:cNvSpPr>
-          <p:nvPr>
-            <p:ph type="body" sz="quarter" idx="3"/>
-          </p:nvPr>
-        </p:nvSpPr>
-        <p:spPr>
-          <a:xfrm>
-            <a:off x="685800" y="4400550"/>
-            <a:ext cx="5486400" cy="3600450"/>
-          </a:xfrm>
-          <a:prstGeom prst="rect">
-            <a:avLst/>
-          </a:prstGeom>
-        </p:spPr>
-        <p:txBody>
-          <a:bodyPr vert="horz" lIns="91440" tIns="45720" rIns="91440" bIns="45720" rtlCol="0"/>
-          <a:lstStyle/>
-          <a:p>
-            <a:pPr lvl="0"/>
-            <a:r>
-              <a:rPr lang="en-US"/>
-              <a:t>Click to edit Master text styles</a:t>
-            </a:r>
-          </a:p>
-          <a:p>
-            <a:pPr lvl="1"/>
-            <a:r>
-              <a:rPr lang="en-US"/>
-              <a:t>Second level</a:t>
-            </a:r>
-          </a:p>
-          <a:p>
-            <a:pPr lvl="2"/>
-            <a:r>
-              <a:rPr lang="en-US"/>
-              <a:t>Third level</a:t>
-            </a:r>
-          </a:p>
-          <a:p>
-            <a:pPr lvl="3"/>
-            <a:r>
-              <a:rPr lang="en-US"/>
-              <a:t>Fourth level</a:t>
-            </a:r>
-          </a:p>
-          <a:p>
-            <a:pPr lvl="4"/>
-            <a:r>
-              <a:rPr lang="en-US"/>
-              <a:t>Fifth level</a:t>
-            </a:r>
-          </a:p>
-        </p:txBody>
-      </p:sp>
-      <p:sp>
-        <p:nvSpPr>
-          <p:cNvPr id="6" name="Footer Placeholder 5"/>
-          <p:cNvSpPr>
-            <a:spLocks noGrp="1"/>
-          </p:cNvSpPr>
-          <p:nvPr>
-            <p:ph type="ftr" sz="quarter" idx="4"/>
-          </p:nvPr>
-        </p:nvSpPr>
-        <p:spPr>
-          <a:xfrm>
-            <a:off x="0" y="8685213"/>
-            <a:ext cx="2971800" cy="458787"/>
-          </a:xfrm>
-          <a:prstGeom prst="rect">
-            <a:avLst/>
-          </a:prstGeom>
-        </p:spPr>
-        <p:txBody>
-          <a:bodyPr vert="horz" lIns="91440" tIns="45720" rIns="91440" bIns="45720" rtlCol="0" anchor="b"/>
-          <a:lstStyle>
-            <a:lvl1pPr algn="l">
-              <a:defRPr sz="1200"/>
-            </a:lvl1pPr>
-          </a:lstStyle>
-          <a:p>
-            <a:endParaRPr lang="en-US"/>
-          </a:p>
-        </p:txBody>
-      </p:sp>
-      <p:sp>
-        <p:nvSpPr>
-          <p:cNvPr id="7" name="Slide Number Placeholder 6"/>
-          <p:cNvSpPr>
-            <a:spLocks noGrp="1"/>
-          </p:cNvSpPr>
-          <p:nvPr>
-            <p:ph type="sldNum" sz="quarter" idx="5"/>
-          </p:nvPr>
-        </p:nvSpPr>
-        <p:spPr>
-          <a:xfrm>
-            <a:off x="3884613" y="8685213"/>
-            <a:ext cx="2971800" cy="458787"/>
-          </a:xfrm>
-          <a:prstGeom prst="rect">
-            <a:avLst/>
-          </a:prstGeom>
-        </p:spPr>
-        <p:txBody>
-          <a:bodyPr vert="horz" lIns="91440" tIns="45720" rIns="91440" bIns="45720" rtlCol="0" anchor="b"/>
-          <a:lstStyle>
-            <a:lvl1pPr algn="r">
-              <a:defRPr sz="1200"/>
-            </a:lvl1pPr>
-          </a:lstStyle>
-          <a:p>
-            <a:fld id="{CE5E9CC1-C706-0F49-92D6-E571CC5EEA8F}" type="slidenum">
-              <a:rPr lang="en-US"/>
-              <a:t>‹#›</a:t>
-            </a:fld>
-            <a:endParaRPr lang="en-US"/>
-          </a:p>
-        </p:txBody>
-      </p:sp>
     </p:spTree>
     <p:extLst>
       <p:ext uri="{BB962C8B-B14F-4D97-AF65-F5344CB8AC3E}">
-        <p14:creationId xmlns:p14="http://schemas.microsoft.com/office/powerpoint/2010/main" val="1024086991"/>
+        <p14:creationId xmlns:p14="http://schemas.microsoft.com/office/powerpoint/2010/main" val="2359497465"/>
       </p:ext>
     </p:extLst>
   </p:cSld>
@@ -510,10 +291,6 @@
           <a:bodyPr/>
           <a:lstStyle/>
           <a:p>
-            <a:r>
-              <a:rPr lang="en-US" dirty="0"/>
-              <a:t/>
-            </a:r>
             <a:endParaRPr lang="en-US" dirty="0"/>
           </a:p>
         </p:txBody>
@@ -598,10 +375,6 @@
           <a:bodyPr/>
           <a:lstStyle/>
           <a:p>
-            <a:r>
-              <a:rPr lang="en-US" dirty="0"/>
-              <a:t/>
-            </a:r>
             <a:endParaRPr lang="en-US" dirty="0"/>
           </a:p>
         </p:txBody>
@@ -686,10 +459,6 @@
           <a:bodyPr/>
           <a:lstStyle/>
           <a:p>
-            <a:r>
-              <a:rPr lang="en-US" dirty="0"/>
-              <a:t/>
-            </a:r>
             <a:endParaRPr lang="en-US" dirty="0"/>
           </a:p>
         </p:txBody>
@@ -774,10 +543,6 @@
           <a:bodyPr/>
           <a:lstStyle/>
           <a:p>
-            <a:r>
-              <a:rPr lang="en-US" dirty="0"/>
-              <a:t/>
-            </a:r>
             <a:endParaRPr lang="en-US" dirty="0"/>
           </a:p>
         </p:txBody>
@@ -862,10 +627,6 @@
           <a:bodyPr/>
           <a:lstStyle/>
           <a:p>
-            <a:r>
-              <a:rPr lang="en-US" dirty="0"/>
-              <a:t/>
-            </a:r>
             <a:endParaRPr lang="en-US" dirty="0"/>
           </a:p>
         </p:txBody>
@@ -950,10 +711,6 @@
           <a:bodyPr/>
           <a:lstStyle/>
           <a:p>
-            <a:r>
-              <a:rPr lang="en-US" dirty="0"/>
-              <a:t/>
-            </a:r>
             <a:endParaRPr lang="en-US" dirty="0"/>
           </a:p>
         </p:txBody>
@@ -1038,10 +795,6 @@
           <a:bodyPr/>
           <a:lstStyle/>
           <a:p>
-            <a:r>
-              <a:rPr lang="en-US" dirty="0"/>
-              <a:t/>
-            </a:r>
             <a:endParaRPr lang="en-US" dirty="0"/>
           </a:p>
         </p:txBody>
@@ -1126,10 +879,6 @@
           <a:bodyPr/>
           <a:lstStyle/>
           <a:p>
-            <a:r>
-              <a:rPr lang="en-US" dirty="0"/>
-              <a:t/>
-            </a:r>
             <a:endParaRPr lang="en-US" dirty="0"/>
           </a:p>
         </p:txBody>
@@ -1214,10 +963,6 @@
           <a:bodyPr/>
           <a:lstStyle/>
           <a:p>
-            <a:r>
-              <a:rPr lang="en-US" dirty="0"/>
-              <a:t/>
-            </a:r>
             <a:endParaRPr lang="en-US" dirty="0"/>
           </a:p>
         </p:txBody>
@@ -1302,10 +1047,6 @@
           <a:bodyPr/>
           <a:lstStyle/>
           <a:p>
-            <a:r>
-              <a:rPr lang="en-US" dirty="0"/>
-              <a:t/>
-            </a:r>
             <a:endParaRPr lang="en-US" dirty="0"/>
           </a:p>
         </p:txBody>
@@ -1390,10 +1131,6 @@
           <a:bodyPr/>
           <a:lstStyle/>
           <a:p>
-            <a:r>
-              <a:rPr lang="en-US" dirty="0"/>
-              <a:t/>
-            </a:r>
             <a:endParaRPr lang="en-US" dirty="0"/>
           </a:p>
         </p:txBody>
@@ -1467,6 +1204,11 @@
 <file path=ppt/slideMasters/slideMaster1.xml><?xml version="1.0" encoding="utf-8"?>
 <p:sldMaster xmlns:a="http://schemas.openxmlformats.org/drawingml/2006/main" xmlns:r="http://schemas.openxmlformats.org/officeDocument/2006/relationships" xmlns:p="http://schemas.openxmlformats.org/presentationml/2006/main">
   <p:cSld>
+    <p:bg>
+      <p:bgRef idx="1001">
+        <a:schemeClr val="bg1"/>
+      </p:bgRef>
+    </p:bg>
     <p:spTree>
       <p:nvGrpSpPr>
         <p:cNvPr id="1" name=""/>
@@ -1777,6 +1519,13 @@
           </a:solidFill>
           <a:ln/>
         </p:spPr>
+        <p:txBody>
+          <a:bodyPr/>
+          <a:lstStyle/>
+          <a:p>
+            <a:endParaRPr lang="en-IN"/>
+          </a:p>
+        </p:txBody>
       </p:sp>
       <p:sp>
         <p:nvSpPr>
@@ -1799,7 +1548,7 @@
           <a:bodyPr wrap="square" rtlCol="0" anchor="ctr"/>
           <a:lstStyle/>
           <a:p>
-            <a:pPr indent="0" marL="0">
+            <a:pPr marL="0" indent="0">
               <a:buNone/>
             </a:pPr>
             <a:r>
@@ -1836,6 +1585,13 @@
           </a:solidFill>
           <a:ln/>
         </p:spPr>
+        <p:txBody>
+          <a:bodyPr/>
+          <a:lstStyle/>
+          <a:p>
+            <a:endParaRPr lang="en-IN"/>
+          </a:p>
+        </p:txBody>
       </p:sp>
       <p:sp>
         <p:nvSpPr>
@@ -1858,7 +1614,7 @@
           <a:bodyPr wrap="square" rtlCol="0" anchor="ctr"/>
           <a:lstStyle/>
           <a:p>
-            <a:pPr indent="0" marL="0">
+            <a:pPr marL="0" indent="0">
               <a:lnSpc>
                 <a:spcPct val="130000"/>
               </a:lnSpc>
@@ -1878,7 +1634,7 @@
             <a:endParaRPr lang="en-US" sz="1900" dirty="0"/>
           </a:p>
           <a:p>
-            <a:pPr indent="0" marL="0">
+            <a:pPr marL="0" indent="0">
               <a:lnSpc>
                 <a:spcPct val="130000"/>
               </a:lnSpc>
@@ -1920,7 +1676,7 @@
           <a:bodyPr wrap="square" rtlCol="0" anchor="ctr"/>
           <a:lstStyle/>
           <a:p>
-            <a:pPr indent="0" marL="0">
+            <a:pPr marL="0" indent="0">
               <a:buNone/>
             </a:pPr>
             <a:r>
@@ -1982,6 +1738,13 @@
           </a:solidFill>
           <a:ln/>
         </p:spPr>
+        <p:txBody>
+          <a:bodyPr/>
+          <a:lstStyle/>
+          <a:p>
+            <a:endParaRPr lang="en-IN"/>
+          </a:p>
+        </p:txBody>
       </p:sp>
       <p:sp>
         <p:nvSpPr>
@@ -2004,7 +1767,7 @@
           <a:bodyPr wrap="square" rtlCol="0" anchor="ctr"/>
           <a:lstStyle/>
           <a:p>
-            <a:pPr indent="0" marL="0">
+            <a:pPr marL="0" indent="0">
               <a:buNone/>
             </a:pPr>
             <a:r>
@@ -2043,7 +1806,7 @@
           <a:bodyPr wrap="square" rtlCol="0" anchor="ctr"/>
           <a:lstStyle/>
           <a:p>
-            <a:pPr indent="0" marL="0">
+            <a:pPr marL="0" indent="0">
               <a:buNone/>
             </a:pPr>
             <a:r>
@@ -2082,6 +1845,13 @@
           </a:solidFill>
           <a:ln/>
         </p:spPr>
+        <p:txBody>
+          <a:bodyPr/>
+          <a:lstStyle/>
+          <a:p>
+            <a:endParaRPr lang="en-IN"/>
+          </a:p>
+        </p:txBody>
       </p:sp>
       <p:sp>
         <p:nvSpPr>
@@ -2104,7 +1874,7 @@
           <a:bodyPr wrap="square" rtlCol="0" anchor="ctr"/>
           <a:lstStyle/>
           <a:p>
-            <a:pPr algn="ctr" indent="0" marL="0">
+            <a:pPr marL="0" indent="0" algn="ctr">
               <a:buNone/>
             </a:pPr>
             <a:r>
@@ -2140,7 +1910,7 @@
           <a:bodyPr wrap="square" rtlCol="0" anchor="ctr"/>
           <a:lstStyle/>
           <a:p>
-            <a:pPr indent="0" marL="0">
+            <a:pPr marL="0" indent="0">
               <a:buNone/>
             </a:pPr>
             <a:r>
@@ -2179,6 +1949,13 @@
           </a:solidFill>
           <a:ln/>
         </p:spPr>
+        <p:txBody>
+          <a:bodyPr/>
+          <a:lstStyle/>
+          <a:p>
+            <a:endParaRPr lang="en-IN"/>
+          </a:p>
+        </p:txBody>
       </p:sp>
       <p:sp>
         <p:nvSpPr>
@@ -2201,7 +1978,7 @@
           <a:bodyPr wrap="square" rtlCol="0" anchor="ctr"/>
           <a:lstStyle/>
           <a:p>
-            <a:pPr algn="ctr" indent="0" marL="0">
+            <a:pPr marL="0" indent="0" algn="ctr">
               <a:buNone/>
             </a:pPr>
             <a:r>
@@ -2240,6 +2017,13 @@
           </a:solidFill>
           <a:ln/>
         </p:spPr>
+        <p:txBody>
+          <a:bodyPr/>
+          <a:lstStyle/>
+          <a:p>
+            <a:endParaRPr lang="en-IN"/>
+          </a:p>
+        </p:txBody>
       </p:sp>
       <p:sp>
         <p:nvSpPr>
@@ -2262,7 +2046,7 @@
           <a:bodyPr wrap="square" rtlCol="0" anchor="ctr"/>
           <a:lstStyle/>
           <a:p>
-            <a:pPr algn="ctr" indent="0" marL="0">
+            <a:pPr marL="0" indent="0" algn="ctr">
               <a:buNone/>
             </a:pPr>
             <a:r>
@@ -2298,7 +2082,7 @@
           <a:bodyPr wrap="square" rtlCol="0" anchor="ctr"/>
           <a:lstStyle/>
           <a:p>
-            <a:pPr indent="0" marL="0">
+            <a:pPr marL="0" indent="0">
               <a:buNone/>
             </a:pPr>
             <a:r>
@@ -2337,6 +2121,13 @@
           </a:solidFill>
           <a:ln/>
         </p:spPr>
+        <p:txBody>
+          <a:bodyPr/>
+          <a:lstStyle/>
+          <a:p>
+            <a:endParaRPr lang="en-IN"/>
+          </a:p>
+        </p:txBody>
       </p:sp>
       <p:sp>
         <p:nvSpPr>
@@ -2359,7 +2150,7 @@
           <a:bodyPr wrap="square" rtlCol="0" anchor="ctr"/>
           <a:lstStyle/>
           <a:p>
-            <a:pPr algn="ctr" indent="0" marL="0">
+            <a:pPr marL="0" indent="0" algn="ctr">
               <a:buNone/>
             </a:pPr>
             <a:r>
@@ -2398,6 +2189,13 @@
           </a:solidFill>
           <a:ln/>
         </p:spPr>
+        <p:txBody>
+          <a:bodyPr/>
+          <a:lstStyle/>
+          <a:p>
+            <a:endParaRPr lang="en-IN"/>
+          </a:p>
+        </p:txBody>
       </p:sp>
       <p:sp>
         <p:nvSpPr>
@@ -2420,7 +2218,7 @@
           <a:bodyPr wrap="square" rtlCol="0" anchor="ctr"/>
           <a:lstStyle/>
           <a:p>
-            <a:pPr algn="ctr" indent="0" marL="0">
+            <a:pPr marL="0" indent="0" algn="ctr">
               <a:buNone/>
             </a:pPr>
             <a:r>
@@ -2456,7 +2254,7 @@
           <a:bodyPr wrap="square" rtlCol="0" anchor="ctr"/>
           <a:lstStyle/>
           <a:p>
-            <a:pPr indent="0" marL="0">
+            <a:pPr marL="0" indent="0">
               <a:buNone/>
             </a:pPr>
             <a:r>
@@ -2495,6 +2293,13 @@
           </a:solidFill>
           <a:ln/>
         </p:spPr>
+        <p:txBody>
+          <a:bodyPr/>
+          <a:lstStyle/>
+          <a:p>
+            <a:endParaRPr lang="en-IN"/>
+          </a:p>
+        </p:txBody>
       </p:sp>
       <p:sp>
         <p:nvSpPr>
@@ -2517,7 +2322,7 @@
           <a:bodyPr wrap="square" rtlCol="0" anchor="ctr"/>
           <a:lstStyle/>
           <a:p>
-            <a:pPr algn="ctr" indent="0" marL="0">
+            <a:pPr marL="0" indent="0" algn="ctr">
               <a:buNone/>
             </a:pPr>
             <a:r>
@@ -2556,6 +2361,13 @@
           </a:solidFill>
           <a:ln/>
         </p:spPr>
+        <p:txBody>
+          <a:bodyPr/>
+          <a:lstStyle/>
+          <a:p>
+            <a:endParaRPr lang="en-IN"/>
+          </a:p>
+        </p:txBody>
       </p:sp>
       <p:sp>
         <p:nvSpPr>
@@ -2578,7 +2390,7 @@
           <a:bodyPr wrap="square" rtlCol="0" anchor="ctr"/>
           <a:lstStyle/>
           <a:p>
-            <a:pPr algn="ctr" indent="0" marL="0">
+            <a:pPr marL="0" indent="0" algn="ctr">
               <a:buNone/>
             </a:pPr>
             <a:r>
@@ -2614,7 +2426,7 @@
           <a:bodyPr wrap="square" rtlCol="0" anchor="ctr"/>
           <a:lstStyle/>
           <a:p>
-            <a:pPr indent="0" marL="0">
+            <a:pPr marL="0" indent="0">
               <a:buNone/>
             </a:pPr>
             <a:r>
@@ -2653,6 +2465,13 @@
           </a:solidFill>
           <a:ln/>
         </p:spPr>
+        <p:txBody>
+          <a:bodyPr/>
+          <a:lstStyle/>
+          <a:p>
+            <a:endParaRPr lang="en-IN"/>
+          </a:p>
+        </p:txBody>
       </p:sp>
       <p:sp>
         <p:nvSpPr>
@@ -2675,7 +2494,7 @@
           <a:bodyPr wrap="square" rtlCol="0" anchor="ctr"/>
           <a:lstStyle/>
           <a:p>
-            <a:pPr algn="ctr" indent="0" marL="0">
+            <a:pPr marL="0" indent="0" algn="ctr">
               <a:buNone/>
             </a:pPr>
             <a:r>
@@ -2714,7 +2533,7 @@
           <a:bodyPr wrap="square" rtlCol="0" anchor="ctr"/>
           <a:lstStyle/>
           <a:p>
-            <a:pPr algn="ctr" indent="0" marL="0">
+            <a:pPr marL="0" indent="0" algn="ctr">
               <a:buNone/>
             </a:pPr>
             <a:r>
@@ -2776,6 +2595,13 @@
           </a:solidFill>
           <a:ln/>
         </p:spPr>
+        <p:txBody>
+          <a:bodyPr/>
+          <a:lstStyle/>
+          <a:p>
+            <a:endParaRPr lang="en-IN"/>
+          </a:p>
+        </p:txBody>
       </p:sp>
       <p:sp>
         <p:nvSpPr>
@@ -2798,63 +2624,12 @@
           <a:bodyPr wrap="square" rtlCol="0" anchor="ctr"/>
           <a:lstStyle/>
           <a:p>
-            <a:pPr algn="ctr" indent="0" marL="0">
+            <a:pPr marL="0" indent="0" algn="ctr">
               <a:lnSpc>
                 <a:spcPct val="160000"/>
               </a:lnSpc>
               <a:buNone/>
             </a:pPr>
-            <a:r>
-              <a:rPr lang="en-US" sz="2600" dirty="0">
-                <a:solidFill>
-                  <a:srgbClr val="FFFFFF"/>
-                </a:solidFill>
-                <a:latin typeface="Segoe UI" pitchFamily="34" charset="0"/>
-                <a:ea typeface="Segoe UI" pitchFamily="34" charset="-122"/>
-                <a:cs typeface="Segoe UI" pitchFamily="34" charset="-120"/>
-              </a:rPr>
-              <a:t>The agent is built.</a:t>
-            </a:r>
-            <a:endParaRPr lang="en-US" sz="2600" dirty="0"/>
-          </a:p>
-          <a:p>
-            <a:pPr algn="ctr" indent="0" marL="0">
-              <a:lnSpc>
-                <a:spcPct val="160000"/>
-              </a:lnSpc>
-              <a:buNone/>
-            </a:pPr>
-            <a:r>
-              <a:rPr lang="en-US" sz="2600" dirty="0">
-                <a:solidFill>
-                  <a:srgbClr val="FFFFFF"/>
-                </a:solidFill>
-                <a:latin typeface="Segoe UI" pitchFamily="34" charset="0"/>
-                <a:ea typeface="Segoe UI" pitchFamily="34" charset="-122"/>
-                <a:cs typeface="Segoe UI" pitchFamily="34" charset="-120"/>
-              </a:rPr>
-              <a:t>The constraints are mapped.</a:t>
-            </a:r>
-            <a:endParaRPr lang="en-US" sz="2600" dirty="0"/>
-          </a:p>
-          <a:p>
-            <a:pPr algn="ctr" indent="0" marL="0">
-              <a:lnSpc>
-                <a:spcPct val="160000"/>
-              </a:lnSpc>
-              <a:buNone/>
-            </a:pPr>
-            <a:r>
-              <a:rPr lang="en-US" sz="2600" dirty="0">
-                <a:solidFill>
-                  <a:srgbClr val="FFFFFF"/>
-                </a:solidFill>
-                <a:latin typeface="Segoe UI" pitchFamily="34" charset="0"/>
-                <a:ea typeface="Segoe UI" pitchFamily="34" charset="-122"/>
-                <a:cs typeface="Segoe UI" pitchFamily="34" charset="-120"/>
-              </a:rPr>
-              <a:t>The path to production is clear.</a:t>
-            </a:r>
             <a:endParaRPr lang="en-US" sz="2600" dirty="0"/>
           </a:p>
         </p:txBody>
@@ -2878,6 +2653,13 @@
           </a:solidFill>
           <a:ln/>
         </p:spPr>
+        <p:txBody>
+          <a:bodyPr/>
+          <a:lstStyle/>
+          <a:p>
+            <a:endParaRPr lang="en-IN"/>
+          </a:p>
+        </p:txBody>
       </p:sp>
       <p:sp>
         <p:nvSpPr>
@@ -2887,7 +2669,7 @@
         </p:nvSpPr>
         <p:spPr>
           <a:xfrm>
-            <a:off x="731520" y="3383280"/>
+            <a:off x="731520" y="2278128"/>
             <a:ext cx="7772400" cy="548640"/>
           </a:xfrm>
           <a:prstGeom prst="rect">
@@ -2900,7 +2682,7 @@
           <a:bodyPr wrap="square" rtlCol="0" anchor="ctr"/>
           <a:lstStyle/>
           <a:p>
-            <a:pPr algn="ctr" indent="0" marL="0">
+            <a:pPr marL="0" indent="0" algn="ctr">
               <a:buNone/>
             </a:pPr>
             <a:r>
@@ -2939,7 +2721,7 @@
           <a:bodyPr wrap="square" rtlCol="0" anchor="ctr"/>
           <a:lstStyle/>
           <a:p>
-            <a:pPr algn="ctr" indent="0" marL="0">
+            <a:pPr marL="0" indent="0" algn="ctr">
               <a:buNone/>
             </a:pPr>
             <a:r>
@@ -2997,10 +2779,19 @@
             <a:avLst/>
           </a:prstGeom>
           <a:solidFill>
-            <a:srgbClr val="252423"/>
+            <a:schemeClr val="bg1">
+              <a:lumMod val="95000"/>
+            </a:schemeClr>
           </a:solidFill>
           <a:ln/>
         </p:spPr>
+        <p:txBody>
+          <a:bodyPr/>
+          <a:lstStyle/>
+          <a:p>
+            <a:endParaRPr lang="en-IN"/>
+          </a:p>
+        </p:txBody>
       </p:sp>
       <p:sp>
         <p:nvSpPr>
@@ -3023,7 +2814,7 @@
           <a:bodyPr wrap="square" rtlCol="0" anchor="ctr"/>
           <a:lstStyle/>
           <a:p>
-            <a:pPr indent="0" marL="0">
+            <a:pPr marL="0" indent="0">
               <a:lnSpc>
                 <a:spcPct val="140000"/>
               </a:lnSpc>
@@ -3032,7 +2823,7 @@
             <a:r>
               <a:rPr lang="en-US" sz="2200" i="1" dirty="0">
                 <a:solidFill>
-                  <a:srgbClr val="FFFFFF"/>
+                  <a:srgbClr val="7030A0"/>
                 </a:solidFill>
                 <a:latin typeface="Segoe UI" pitchFamily="34" charset="0"/>
                 <a:ea typeface="Segoe UI" pitchFamily="34" charset="-122"/>
@@ -3040,10 +2831,14 @@
               </a:rPr>
               <a:t>"181 activities. 17 workstreams. 29 people.</a:t>
             </a:r>
-            <a:endParaRPr lang="en-US" sz="2200" dirty="0"/>
-          </a:p>
-          <a:p>
-            <a:pPr indent="0" marL="0">
+            <a:endParaRPr lang="en-US" sz="2200" dirty="0">
+              <a:solidFill>
+                <a:srgbClr val="7030A0"/>
+              </a:solidFill>
+            </a:endParaRPr>
+          </a:p>
+          <a:p>
+            <a:pPr marL="0" indent="0">
               <a:lnSpc>
                 <a:spcPct val="140000"/>
               </a:lnSpc>
@@ -3052,7 +2847,7 @@
             <a:r>
               <a:rPr lang="en-US" sz="2200" i="1" dirty="0">
                 <a:solidFill>
-                  <a:srgbClr val="FFFFFF"/>
+                  <a:srgbClr val="7030A0"/>
                 </a:solidFill>
                 <a:latin typeface="Segoe UI" pitchFamily="34" charset="0"/>
                 <a:ea typeface="Segoe UI" pitchFamily="34" charset="-122"/>
@@ -3060,7 +2855,11 @@
               </a:rPr>
               <a:t>One shared Excel file as the source of truth."</a:t>
             </a:r>
-            <a:endParaRPr lang="en-US" sz="2200" dirty="0"/>
+            <a:endParaRPr lang="en-US" sz="2200" dirty="0">
+              <a:solidFill>
+                <a:srgbClr val="7030A0"/>
+              </a:solidFill>
+            </a:endParaRPr>
           </a:p>
         </p:txBody>
       </p:sp>
@@ -3083,6 +2882,13 @@
           </a:solidFill>
           <a:ln/>
         </p:spPr>
+        <p:txBody>
+          <a:bodyPr/>
+          <a:lstStyle/>
+          <a:p>
+            <a:endParaRPr lang="en-IN"/>
+          </a:p>
+        </p:txBody>
       </p:sp>
       <p:sp>
         <p:nvSpPr>
@@ -3105,13 +2911,15 @@
           <a:bodyPr wrap="square" rtlCol="0" anchor="ctr"/>
           <a:lstStyle/>
           <a:p>
-            <a:pPr indent="0" marL="0">
+            <a:pPr marL="0" indent="0">
               <a:buNone/>
             </a:pPr>
             <a:r>
               <a:rPr lang="en-US" sz="1600" dirty="0">
                 <a:solidFill>
-                  <a:srgbClr val="C0C0C0"/>
+                  <a:schemeClr val="bg2">
+                    <a:lumMod val="50000"/>
+                  </a:schemeClr>
                 </a:solidFill>
                 <a:latin typeface="Segoe UI" pitchFamily="34" charset="0"/>
                 <a:ea typeface="Segoe UI" pitchFamily="34" charset="-122"/>
@@ -3119,7 +2927,13 @@
               </a:rPr>
               <a:t>→  No real-time visibility — you have to open the spreadsheet</a:t>
             </a:r>
-            <a:endParaRPr lang="en-US" sz="1600" dirty="0"/>
+            <a:endParaRPr lang="en-US" sz="1600" dirty="0">
+              <a:solidFill>
+                <a:schemeClr val="bg2">
+                  <a:lumMod val="50000"/>
+                </a:schemeClr>
+              </a:solidFill>
+            </a:endParaRPr>
           </a:p>
         </p:txBody>
       </p:sp>
@@ -3144,13 +2958,15 @@
           <a:bodyPr wrap="square" rtlCol="0" anchor="ctr"/>
           <a:lstStyle/>
           <a:p>
-            <a:pPr indent="0" marL="0">
+            <a:pPr marL="0" indent="0">
               <a:buNone/>
             </a:pPr>
             <a:r>
               <a:rPr lang="en-US" sz="1600" dirty="0">
                 <a:solidFill>
-                  <a:srgbClr val="C0C0C0"/>
+                  <a:schemeClr val="bg2">
+                    <a:lumMod val="50000"/>
+                  </a:schemeClr>
                 </a:solidFill>
                 <a:latin typeface="Segoe UI" pitchFamily="34" charset="0"/>
                 <a:ea typeface="Segoe UI" pitchFamily="34" charset="-122"/>
@@ -3158,7 +2974,13 @@
               </a:rPr>
               <a:t>→  No dependency tracking — blocked items go unnoticed</a:t>
             </a:r>
-            <a:endParaRPr lang="en-US" sz="1600" dirty="0"/>
+            <a:endParaRPr lang="en-US" sz="1600" dirty="0">
+              <a:solidFill>
+                <a:schemeClr val="bg2">
+                  <a:lumMod val="50000"/>
+                </a:schemeClr>
+              </a:solidFill>
+            </a:endParaRPr>
           </a:p>
         </p:txBody>
       </p:sp>
@@ -3183,13 +3005,15 @@
           <a:bodyPr wrap="square" rtlCol="0" anchor="ctr"/>
           <a:lstStyle/>
           <a:p>
-            <a:pPr indent="0" marL="0">
+            <a:pPr marL="0" indent="0">
               <a:buNone/>
             </a:pPr>
             <a:r>
               <a:rPr lang="en-US" sz="1600" dirty="0">
                 <a:solidFill>
-                  <a:srgbClr val="C0C0C0"/>
+                  <a:schemeClr val="bg2">
+                    <a:lumMod val="50000"/>
+                  </a:schemeClr>
                 </a:solidFill>
                 <a:latin typeface="Segoe UI" pitchFamily="34" charset="0"/>
                 <a:ea typeface="Segoe UI" pitchFamily="34" charset="-122"/>
@@ -3197,7 +3021,13 @@
               </a:rPr>
               <a:t>→  No alerts — overdue steps discovered in weekly meetings</a:t>
             </a:r>
-            <a:endParaRPr lang="en-US" sz="1600" dirty="0"/>
+            <a:endParaRPr lang="en-US" sz="1600" dirty="0">
+              <a:solidFill>
+                <a:schemeClr val="bg2">
+                  <a:lumMod val="50000"/>
+                </a:schemeClr>
+              </a:solidFill>
+            </a:endParaRPr>
           </a:p>
         </p:txBody>
       </p:sp>
@@ -3222,13 +3052,15 @@
           <a:bodyPr wrap="square" rtlCol="0" anchor="ctr"/>
           <a:lstStyle/>
           <a:p>
-            <a:pPr indent="0" marL="0">
+            <a:pPr marL="0" indent="0">
               <a:buNone/>
             </a:pPr>
             <a:r>
               <a:rPr lang="en-US" sz="1600" dirty="0">
                 <a:solidFill>
-                  <a:srgbClr val="C0C0C0"/>
+                  <a:schemeClr val="bg2">
+                    <a:lumMod val="50000"/>
+                  </a:schemeClr>
                 </a:solidFill>
                 <a:latin typeface="Segoe UI" pitchFamily="34" charset="0"/>
                 <a:ea typeface="Segoe UI" pitchFamily="34" charset="-122"/>
@@ -3236,7 +3068,13 @@
               </a:rPr>
               <a:t>→  Leadership wants dashboards, not raw Excel rows</a:t>
             </a:r>
-            <a:endParaRPr lang="en-US" sz="1600" dirty="0"/>
+            <a:endParaRPr lang="en-US" sz="1600" dirty="0">
+              <a:solidFill>
+                <a:schemeClr val="bg2">
+                  <a:lumMod val="50000"/>
+                </a:schemeClr>
+              </a:solidFill>
+            </a:endParaRPr>
           </a:p>
         </p:txBody>
       </p:sp>
@@ -3261,7 +3099,7 @@
           <a:bodyPr wrap="square" rtlCol="0" anchor="ctr"/>
           <a:lstStyle/>
           <a:p>
-            <a:pPr indent="0" marL="0">
+            <a:pPr marL="0" indent="0">
               <a:lnSpc>
                 <a:spcPct val="125000"/>
               </a:lnSpc>
@@ -3270,7 +3108,7 @@
             <a:r>
               <a:rPr lang="en-US" sz="1400" b="1" dirty="0">
                 <a:solidFill>
-                  <a:srgbClr val="FFFFFF"/>
+                  <a:srgbClr val="7030A0"/>
                 </a:solidFill>
                 <a:latin typeface="Segoe UI" pitchFamily="34" charset="0"/>
                 <a:ea typeface="Segoe UI" pitchFamily="34" charset="-122"/>
@@ -3278,7 +3116,11 @@
               </a:rPr>
               <a:t>Question: Could an intelligent Teams agent solve this — reading the Excel, answering questions, tracking dependencies, and keeping everyone on the same page?</a:t>
             </a:r>
-            <a:endParaRPr lang="en-US" sz="1400" dirty="0"/>
+            <a:endParaRPr lang="en-US" sz="1400" dirty="0">
+              <a:solidFill>
+                <a:srgbClr val="7030A0"/>
+              </a:solidFill>
+            </a:endParaRPr>
           </a:p>
         </p:txBody>
       </p:sp>
@@ -3326,6 +3168,13 @@
           </a:solidFill>
           <a:ln/>
         </p:spPr>
+        <p:txBody>
+          <a:bodyPr/>
+          <a:lstStyle/>
+          <a:p>
+            <a:endParaRPr lang="en-IN"/>
+          </a:p>
+        </p:txBody>
       </p:sp>
       <p:sp>
         <p:nvSpPr>
@@ -3348,7 +3197,7 @@
           <a:bodyPr wrap="square" rtlCol="0" anchor="ctr"/>
           <a:lstStyle/>
           <a:p>
-            <a:pPr indent="0" marL="0">
+            <a:pPr marL="0" indent="0">
               <a:buNone/>
             </a:pPr>
             <a:r>
@@ -3387,7 +3236,7 @@
           <a:bodyPr wrap="square" rtlCol="0" anchor="ctr"/>
           <a:lstStyle/>
           <a:p>
-            <a:pPr indent="0" marL="0">
+            <a:pPr marL="0" indent="0">
               <a:buNone/>
             </a:pPr>
             <a:r>
@@ -3426,6 +3275,13 @@
           </a:solidFill>
           <a:ln/>
         </p:spPr>
+        <p:txBody>
+          <a:bodyPr/>
+          <a:lstStyle/>
+          <a:p>
+            <a:endParaRPr lang="en-IN"/>
+          </a:p>
+        </p:txBody>
       </p:sp>
       <p:sp>
         <p:nvSpPr>
@@ -3448,7 +3304,7 @@
           <a:bodyPr wrap="square" rtlCol="0" anchor="ctr"/>
           <a:lstStyle/>
           <a:p>
-            <a:pPr indent="0" marL="0">
+            <a:pPr marL="0" indent="0">
               <a:buNone/>
             </a:pPr>
             <a:r>
@@ -3484,7 +3340,7 @@
           <a:bodyPr wrap="square" rtlCol="0" anchor="ctr"/>
           <a:lstStyle/>
           <a:p>
-            <a:pPr indent="0" marL="0">
+            <a:pPr marL="0" indent="0">
               <a:buNone/>
             </a:pPr>
             <a:r>
@@ -3523,7 +3379,7 @@
           <a:bodyPr wrap="square" rtlCol="0" anchor="ctr"/>
           <a:lstStyle/>
           <a:p>
-            <a:pPr indent="0" marL="0">
+            <a:pPr marL="0" indent="0">
               <a:lnSpc>
                 <a:spcPct val="125000"/>
               </a:lnSpc>
@@ -3543,7 +3399,7 @@
             <a:endParaRPr lang="en-US" sz="1100" dirty="0"/>
           </a:p>
           <a:p>
-            <a:pPr indent="0" marL="0">
+            <a:pPr marL="0" indent="0">
               <a:lnSpc>
                 <a:spcPct val="125000"/>
               </a:lnSpc>
@@ -3563,7 +3419,7 @@
             <a:endParaRPr lang="en-US" sz="1100" dirty="0"/>
           </a:p>
           <a:p>
-            <a:pPr indent="0" marL="0">
+            <a:pPr marL="0" indent="0">
               <a:lnSpc>
                 <a:spcPct val="125000"/>
               </a:lnSpc>
@@ -3605,6 +3461,13 @@
           </a:solidFill>
           <a:ln/>
         </p:spPr>
+        <p:txBody>
+          <a:bodyPr/>
+          <a:lstStyle/>
+          <a:p>
+            <a:endParaRPr lang="en-IN"/>
+          </a:p>
+        </p:txBody>
       </p:sp>
       <p:sp>
         <p:nvSpPr>
@@ -3627,7 +3490,7 @@
           <a:bodyPr wrap="square" rtlCol="0" anchor="ctr"/>
           <a:lstStyle/>
           <a:p>
-            <a:pPr indent="0" marL="0">
+            <a:pPr marL="0" indent="0">
               <a:buNone/>
             </a:pPr>
             <a:r>
@@ -3663,7 +3526,7 @@
           <a:bodyPr wrap="square" rtlCol="0" anchor="ctr"/>
           <a:lstStyle/>
           <a:p>
-            <a:pPr indent="0" marL="0">
+            <a:pPr marL="0" indent="0">
               <a:buNone/>
             </a:pPr>
             <a:r>
@@ -3702,7 +3565,7 @@
           <a:bodyPr wrap="square" rtlCol="0" anchor="ctr"/>
           <a:lstStyle/>
           <a:p>
-            <a:pPr indent="0" marL="0">
+            <a:pPr marL="0" indent="0">
               <a:lnSpc>
                 <a:spcPct val="125000"/>
               </a:lnSpc>
@@ -3722,7 +3585,7 @@
             <a:endParaRPr lang="en-US" sz="1100" dirty="0"/>
           </a:p>
           <a:p>
-            <a:pPr indent="0" marL="0">
+            <a:pPr marL="0" indent="0">
               <a:lnSpc>
                 <a:spcPct val="125000"/>
               </a:lnSpc>
@@ -3742,7 +3605,7 @@
             <a:endParaRPr lang="en-US" sz="1100" dirty="0"/>
           </a:p>
           <a:p>
-            <a:pPr indent="0" marL="0">
+            <a:pPr marL="0" indent="0">
               <a:lnSpc>
                 <a:spcPct val="125000"/>
               </a:lnSpc>
@@ -3784,6 +3647,13 @@
           </a:solidFill>
           <a:ln/>
         </p:spPr>
+        <p:txBody>
+          <a:bodyPr/>
+          <a:lstStyle/>
+          <a:p>
+            <a:endParaRPr lang="en-IN"/>
+          </a:p>
+        </p:txBody>
       </p:sp>
       <p:sp>
         <p:nvSpPr>
@@ -3806,7 +3676,7 @@
           <a:bodyPr wrap="square" rtlCol="0" anchor="ctr"/>
           <a:lstStyle/>
           <a:p>
-            <a:pPr indent="0" marL="0">
+            <a:pPr marL="0" indent="0">
               <a:buNone/>
             </a:pPr>
             <a:r>
@@ -3842,7 +3712,7 @@
           <a:bodyPr wrap="square" rtlCol="0" anchor="ctr"/>
           <a:lstStyle/>
           <a:p>
-            <a:pPr indent="0" marL="0">
+            <a:pPr marL="0" indent="0">
               <a:buNone/>
             </a:pPr>
             <a:r>
@@ -3881,7 +3751,7 @@
           <a:bodyPr wrap="square" rtlCol="0" anchor="ctr"/>
           <a:lstStyle/>
           <a:p>
-            <a:pPr indent="0" marL="0">
+            <a:pPr marL="0" indent="0">
               <a:lnSpc>
                 <a:spcPct val="125000"/>
               </a:lnSpc>
@@ -3901,7 +3771,7 @@
             <a:endParaRPr lang="en-US" sz="1100" dirty="0"/>
           </a:p>
           <a:p>
-            <a:pPr indent="0" marL="0">
+            <a:pPr marL="0" indent="0">
               <a:lnSpc>
                 <a:spcPct val="125000"/>
               </a:lnSpc>
@@ -3921,7 +3791,7 @@
             <a:endParaRPr lang="en-US" sz="1100" dirty="0"/>
           </a:p>
           <a:p>
-            <a:pPr indent="0" marL="0">
+            <a:pPr marL="0" indent="0">
               <a:lnSpc>
                 <a:spcPct val="125000"/>
               </a:lnSpc>
@@ -3963,6 +3833,13 @@
           </a:solidFill>
           <a:ln/>
         </p:spPr>
+        <p:txBody>
+          <a:bodyPr/>
+          <a:lstStyle/>
+          <a:p>
+            <a:endParaRPr lang="en-IN"/>
+          </a:p>
+        </p:txBody>
       </p:sp>
       <p:sp>
         <p:nvSpPr>
@@ -3985,7 +3862,7 @@
           <a:bodyPr wrap="square" rtlCol="0" anchor="ctr"/>
           <a:lstStyle/>
           <a:p>
-            <a:pPr indent="0" marL="0">
+            <a:pPr marL="0" indent="0">
               <a:buNone/>
             </a:pPr>
             <a:r>
@@ -4021,7 +3898,7 @@
           <a:bodyPr wrap="square" rtlCol="0" anchor="ctr"/>
           <a:lstStyle/>
           <a:p>
-            <a:pPr indent="0" marL="0">
+            <a:pPr marL="0" indent="0">
               <a:buNone/>
             </a:pPr>
             <a:r>
@@ -4060,7 +3937,7 @@
           <a:bodyPr wrap="square" rtlCol="0" anchor="ctr"/>
           <a:lstStyle/>
           <a:p>
-            <a:pPr indent="0" marL="0">
+            <a:pPr marL="0" indent="0">
               <a:lnSpc>
                 <a:spcPct val="125000"/>
               </a:lnSpc>
@@ -4080,7 +3957,7 @@
             <a:endParaRPr lang="en-US" sz="1100" dirty="0"/>
           </a:p>
           <a:p>
-            <a:pPr indent="0" marL="0">
+            <a:pPr marL="0" indent="0">
               <a:lnSpc>
                 <a:spcPct val="125000"/>
               </a:lnSpc>
@@ -4100,7 +3977,7 @@
             <a:endParaRPr lang="en-US" sz="1100" dirty="0"/>
           </a:p>
           <a:p>
-            <a:pPr indent="0" marL="0">
+            <a:pPr marL="0" indent="0">
               <a:lnSpc>
                 <a:spcPct val="125000"/>
               </a:lnSpc>
@@ -4142,7 +4019,7 @@
           <a:bodyPr wrap="square" rtlCol="0" anchor="ctr"/>
           <a:lstStyle/>
           <a:p>
-            <a:pPr algn="ctr" indent="0" marL="0">
+            <a:pPr marL="0" indent="0" algn="ctr">
               <a:buNone/>
             </a:pPr>
             <a:r>
@@ -4204,6 +4081,13 @@
           </a:solidFill>
           <a:ln/>
         </p:spPr>
+        <p:txBody>
+          <a:bodyPr/>
+          <a:lstStyle/>
+          <a:p>
+            <a:endParaRPr lang="en-IN"/>
+          </a:p>
+        </p:txBody>
       </p:sp>
       <p:sp>
         <p:nvSpPr>
@@ -4226,7 +4110,7 @@
           <a:bodyPr wrap="square" rtlCol="0" anchor="ctr"/>
           <a:lstStyle/>
           <a:p>
-            <a:pPr indent="0" marL="0">
+            <a:pPr marL="0" indent="0">
               <a:buNone/>
             </a:pPr>
             <a:r>
@@ -4265,7 +4149,7 @@
           <a:bodyPr wrap="square" rtlCol="0" anchor="ctr"/>
           <a:lstStyle/>
           <a:p>
-            <a:pPr indent="0" marL="0">
+            <a:pPr marL="0" indent="0">
               <a:buNone/>
             </a:pPr>
             <a:r>
@@ -4302,6 +4186,13 @@
           </a:solidFill>
           <a:ln/>
         </p:spPr>
+        <p:txBody>
+          <a:bodyPr/>
+          <a:lstStyle/>
+          <a:p>
+            <a:endParaRPr lang="en-IN"/>
+          </a:p>
+        </p:txBody>
       </p:sp>
       <p:sp>
         <p:nvSpPr>
@@ -4324,7 +4215,7 @@
           <a:bodyPr wrap="square" rtlCol="0" anchor="ctr"/>
           <a:lstStyle/>
           <a:p>
-            <a:pPr algn="ctr" indent="0" marL="0">
+            <a:pPr marL="0" indent="0" algn="ctr">
               <a:buNone/>
             </a:pPr>
             <a:r>
@@ -4364,6 +4255,13 @@
             <a:prstDash val="solid"/>
           </a:ln>
         </p:spPr>
+        <p:txBody>
+          <a:bodyPr/>
+          <a:lstStyle/>
+          <a:p>
+            <a:endParaRPr lang="en-IN"/>
+          </a:p>
+        </p:txBody>
       </p:sp>
       <p:sp>
         <p:nvSpPr>
@@ -4386,7 +4284,7 @@
           <a:bodyPr wrap="square" rtlCol="0" anchor="ctr"/>
           <a:lstStyle/>
           <a:p>
-            <a:pPr indent="0" marL="0">
+            <a:pPr marL="0" indent="0">
               <a:buNone/>
             </a:pPr>
             <a:r>
@@ -4425,7 +4323,7 @@
           <a:bodyPr wrap="square" rtlCol="0" anchor="ctr"/>
           <a:lstStyle/>
           <a:p>
-            <a:pPr indent="0" marL="0">
+            <a:pPr marL="0" indent="0">
               <a:buNone/>
             </a:pPr>
             <a:r>
@@ -4464,7 +4362,7 @@
           <a:bodyPr wrap="square" rtlCol="0" anchor="ctr"/>
           <a:lstStyle/>
           <a:p>
-            <a:pPr algn="r" indent="0" marL="0">
+            <a:pPr marL="0" indent="0" algn="r">
               <a:buNone/>
             </a:pPr>
             <a:r>
@@ -4501,6 +4399,13 @@
           </a:solidFill>
           <a:ln/>
         </p:spPr>
+        <p:txBody>
+          <a:bodyPr/>
+          <a:lstStyle/>
+          <a:p>
+            <a:endParaRPr lang="en-IN"/>
+          </a:p>
+        </p:txBody>
       </p:sp>
       <p:sp>
         <p:nvSpPr>
@@ -4523,7 +4428,7 @@
           <a:bodyPr wrap="square" rtlCol="0" anchor="ctr"/>
           <a:lstStyle/>
           <a:p>
-            <a:pPr algn="ctr" indent="0" marL="0">
+            <a:pPr marL="0" indent="0" algn="ctr">
               <a:buNone/>
             </a:pPr>
             <a:r>
@@ -4563,6 +4468,13 @@
             <a:prstDash val="solid"/>
           </a:ln>
         </p:spPr>
+        <p:txBody>
+          <a:bodyPr/>
+          <a:lstStyle/>
+          <a:p>
+            <a:endParaRPr lang="en-IN"/>
+          </a:p>
+        </p:txBody>
       </p:sp>
       <p:sp>
         <p:nvSpPr>
@@ -4585,7 +4497,7 @@
           <a:bodyPr wrap="square" rtlCol="0" anchor="ctr"/>
           <a:lstStyle/>
           <a:p>
-            <a:pPr indent="0" marL="0">
+            <a:pPr marL="0" indent="0">
               <a:buNone/>
             </a:pPr>
             <a:r>
@@ -4624,7 +4536,7 @@
           <a:bodyPr wrap="square" rtlCol="0" anchor="ctr"/>
           <a:lstStyle/>
           <a:p>
-            <a:pPr indent="0" marL="0">
+            <a:pPr marL="0" indent="0">
               <a:buNone/>
             </a:pPr>
             <a:r>
@@ -4663,7 +4575,7 @@
           <a:bodyPr wrap="square" rtlCol="0" anchor="ctr"/>
           <a:lstStyle/>
           <a:p>
-            <a:pPr algn="r" indent="0" marL="0">
+            <a:pPr marL="0" indent="0" algn="r">
               <a:buNone/>
             </a:pPr>
             <a:r>
@@ -4700,6 +4612,13 @@
           </a:solidFill>
           <a:ln/>
         </p:spPr>
+        <p:txBody>
+          <a:bodyPr/>
+          <a:lstStyle/>
+          <a:p>
+            <a:endParaRPr lang="en-IN"/>
+          </a:p>
+        </p:txBody>
       </p:sp>
       <p:sp>
         <p:nvSpPr>
@@ -4722,7 +4641,7 @@
           <a:bodyPr wrap="square" rtlCol="0" anchor="ctr"/>
           <a:lstStyle/>
           <a:p>
-            <a:pPr algn="ctr" indent="0" marL="0">
+            <a:pPr marL="0" indent="0" algn="ctr">
               <a:buNone/>
             </a:pPr>
             <a:r>
@@ -4762,6 +4681,13 @@
             <a:prstDash val="solid"/>
           </a:ln>
         </p:spPr>
+        <p:txBody>
+          <a:bodyPr/>
+          <a:lstStyle/>
+          <a:p>
+            <a:endParaRPr lang="en-IN"/>
+          </a:p>
+        </p:txBody>
       </p:sp>
       <p:sp>
         <p:nvSpPr>
@@ -4784,7 +4710,7 @@
           <a:bodyPr wrap="square" rtlCol="0" anchor="ctr"/>
           <a:lstStyle/>
           <a:p>
-            <a:pPr indent="0" marL="0">
+            <a:pPr marL="0" indent="0">
               <a:buNone/>
             </a:pPr>
             <a:r>
@@ -4823,7 +4749,7 @@
           <a:bodyPr wrap="square" rtlCol="0" anchor="ctr"/>
           <a:lstStyle/>
           <a:p>
-            <a:pPr indent="0" marL="0">
+            <a:pPr marL="0" indent="0">
               <a:buNone/>
             </a:pPr>
             <a:r>
@@ -4862,7 +4788,7 @@
           <a:bodyPr wrap="square" rtlCol="0" anchor="ctr"/>
           <a:lstStyle/>
           <a:p>
-            <a:pPr algn="r" indent="0" marL="0">
+            <a:pPr marL="0" indent="0" algn="r">
               <a:buNone/>
             </a:pPr>
             <a:r>
@@ -4899,6 +4825,13 @@
           </a:solidFill>
           <a:ln/>
         </p:spPr>
+        <p:txBody>
+          <a:bodyPr/>
+          <a:lstStyle/>
+          <a:p>
+            <a:endParaRPr lang="en-IN"/>
+          </a:p>
+        </p:txBody>
       </p:sp>
       <p:sp>
         <p:nvSpPr>
@@ -4921,7 +4854,7 @@
           <a:bodyPr wrap="square" rtlCol="0" anchor="ctr"/>
           <a:lstStyle/>
           <a:p>
-            <a:pPr algn="ctr" indent="0" marL="0">
+            <a:pPr marL="0" indent="0" algn="ctr">
               <a:buNone/>
             </a:pPr>
             <a:r>
@@ -4961,6 +4894,13 @@
             <a:prstDash val="solid"/>
           </a:ln>
         </p:spPr>
+        <p:txBody>
+          <a:bodyPr/>
+          <a:lstStyle/>
+          <a:p>
+            <a:endParaRPr lang="en-IN"/>
+          </a:p>
+        </p:txBody>
       </p:sp>
       <p:sp>
         <p:nvSpPr>
@@ -4983,7 +4923,7 @@
           <a:bodyPr wrap="square" rtlCol="0" anchor="ctr"/>
           <a:lstStyle/>
           <a:p>
-            <a:pPr indent="0" marL="0">
+            <a:pPr marL="0" indent="0">
               <a:buNone/>
             </a:pPr>
             <a:r>
@@ -5022,7 +4962,7 @@
           <a:bodyPr wrap="square" rtlCol="0" anchor="ctr"/>
           <a:lstStyle/>
           <a:p>
-            <a:pPr indent="0" marL="0">
+            <a:pPr marL="0" indent="0">
               <a:buNone/>
             </a:pPr>
             <a:r>
@@ -5061,7 +5001,7 @@
           <a:bodyPr wrap="square" rtlCol="0" anchor="ctr"/>
           <a:lstStyle/>
           <a:p>
-            <a:pPr algn="r" indent="0" marL="0">
+            <a:pPr marL="0" indent="0" algn="r">
               <a:buNone/>
             </a:pPr>
             <a:r>
@@ -5098,6 +5038,13 @@
           </a:solidFill>
           <a:ln/>
         </p:spPr>
+        <p:txBody>
+          <a:bodyPr/>
+          <a:lstStyle/>
+          <a:p>
+            <a:endParaRPr lang="en-IN"/>
+          </a:p>
+        </p:txBody>
       </p:sp>
       <p:sp>
         <p:nvSpPr>
@@ -5120,7 +5067,7 @@
           <a:bodyPr wrap="square" rtlCol="0" anchor="ctr"/>
           <a:lstStyle/>
           <a:p>
-            <a:pPr algn="ctr" indent="0" marL="0">
+            <a:pPr marL="0" indent="0" algn="ctr">
               <a:buNone/>
             </a:pPr>
             <a:r>
@@ -5160,6 +5107,13 @@
             <a:prstDash val="solid"/>
           </a:ln>
         </p:spPr>
+        <p:txBody>
+          <a:bodyPr/>
+          <a:lstStyle/>
+          <a:p>
+            <a:endParaRPr lang="en-IN"/>
+          </a:p>
+        </p:txBody>
       </p:sp>
       <p:sp>
         <p:nvSpPr>
@@ -5182,7 +5136,7 @@
           <a:bodyPr wrap="square" rtlCol="0" anchor="ctr"/>
           <a:lstStyle/>
           <a:p>
-            <a:pPr indent="0" marL="0">
+            <a:pPr marL="0" indent="0">
               <a:buNone/>
             </a:pPr>
             <a:r>
@@ -5221,7 +5175,7 @@
           <a:bodyPr wrap="square" rtlCol="0" anchor="ctr"/>
           <a:lstStyle/>
           <a:p>
-            <a:pPr indent="0" marL="0">
+            <a:pPr marL="0" indent="0">
               <a:buNone/>
             </a:pPr>
             <a:r>
@@ -5260,7 +5214,7 @@
           <a:bodyPr wrap="square" rtlCol="0" anchor="ctr"/>
           <a:lstStyle/>
           <a:p>
-            <a:pPr algn="r" indent="0" marL="0">
+            <a:pPr marL="0" indent="0" algn="r">
               <a:buNone/>
             </a:pPr>
             <a:r>
@@ -5297,6 +5251,13 @@
           </a:solidFill>
           <a:ln/>
         </p:spPr>
+        <p:txBody>
+          <a:bodyPr/>
+          <a:lstStyle/>
+          <a:p>
+            <a:endParaRPr lang="en-IN"/>
+          </a:p>
+        </p:txBody>
       </p:sp>
       <p:sp>
         <p:nvSpPr>
@@ -5319,7 +5280,7 @@
           <a:bodyPr wrap="square" rtlCol="0" anchor="ctr"/>
           <a:lstStyle/>
           <a:p>
-            <a:pPr algn="ctr" indent="0" marL="0">
+            <a:pPr marL="0" indent="0" algn="ctr">
               <a:buNone/>
             </a:pPr>
             <a:r>
@@ -5359,6 +5320,13 @@
             <a:prstDash val="solid"/>
           </a:ln>
         </p:spPr>
+        <p:txBody>
+          <a:bodyPr/>
+          <a:lstStyle/>
+          <a:p>
+            <a:endParaRPr lang="en-IN"/>
+          </a:p>
+        </p:txBody>
       </p:sp>
       <p:sp>
         <p:nvSpPr>
@@ -5381,7 +5349,7 @@
           <a:bodyPr wrap="square" rtlCol="0" anchor="ctr"/>
           <a:lstStyle/>
           <a:p>
-            <a:pPr indent="0" marL="0">
+            <a:pPr marL="0" indent="0">
               <a:buNone/>
             </a:pPr>
             <a:r>
@@ -5420,7 +5388,7 @@
           <a:bodyPr wrap="square" rtlCol="0" anchor="ctr"/>
           <a:lstStyle/>
           <a:p>
-            <a:pPr indent="0" marL="0">
+            <a:pPr marL="0" indent="0">
               <a:buNone/>
             </a:pPr>
             <a:r>
@@ -5459,7 +5427,7 @@
           <a:bodyPr wrap="square" rtlCol="0" anchor="ctr"/>
           <a:lstStyle/>
           <a:p>
-            <a:pPr algn="r" indent="0" marL="0">
+            <a:pPr marL="0" indent="0" algn="r">
               <a:buNone/>
             </a:pPr>
             <a:r>
@@ -5496,6 +5464,13 @@
           </a:solidFill>
           <a:ln/>
         </p:spPr>
+        <p:txBody>
+          <a:bodyPr/>
+          <a:lstStyle/>
+          <a:p>
+            <a:endParaRPr lang="en-IN"/>
+          </a:p>
+        </p:txBody>
       </p:sp>
       <p:sp>
         <p:nvSpPr>
@@ -5518,7 +5493,7 @@
           <a:bodyPr wrap="square" rtlCol="0" anchor="ctr"/>
           <a:lstStyle/>
           <a:p>
-            <a:pPr algn="ctr" indent="0" marL="0">
+            <a:pPr marL="0" indent="0" algn="ctr">
               <a:buNone/>
             </a:pPr>
             <a:r>
@@ -5558,6 +5533,13 @@
             <a:prstDash val="solid"/>
           </a:ln>
         </p:spPr>
+        <p:txBody>
+          <a:bodyPr/>
+          <a:lstStyle/>
+          <a:p>
+            <a:endParaRPr lang="en-IN"/>
+          </a:p>
+        </p:txBody>
       </p:sp>
       <p:sp>
         <p:nvSpPr>
@@ -5580,7 +5562,7 @@
           <a:bodyPr wrap="square" rtlCol="0" anchor="ctr"/>
           <a:lstStyle/>
           <a:p>
-            <a:pPr indent="0" marL="0">
+            <a:pPr marL="0" indent="0">
               <a:buNone/>
             </a:pPr>
             <a:r>
@@ -5619,7 +5601,7 @@
           <a:bodyPr wrap="square" rtlCol="0" anchor="ctr"/>
           <a:lstStyle/>
           <a:p>
-            <a:pPr indent="0" marL="0">
+            <a:pPr marL="0" indent="0">
               <a:buNone/>
             </a:pPr>
             <a:r>
@@ -5658,7 +5640,7 @@
           <a:bodyPr wrap="square" rtlCol="0" anchor="ctr"/>
           <a:lstStyle/>
           <a:p>
-            <a:pPr algn="r" indent="0" marL="0">
+            <a:pPr marL="0" indent="0" algn="r">
               <a:buNone/>
             </a:pPr>
             <a:r>
@@ -5695,6 +5677,13 @@
           </a:solidFill>
           <a:ln/>
         </p:spPr>
+        <p:txBody>
+          <a:bodyPr/>
+          <a:lstStyle/>
+          <a:p>
+            <a:endParaRPr lang="en-IN"/>
+          </a:p>
+        </p:txBody>
       </p:sp>
       <p:sp>
         <p:nvSpPr>
@@ -5717,7 +5706,7 @@
           <a:bodyPr wrap="square" rtlCol="0" anchor="ctr"/>
           <a:lstStyle/>
           <a:p>
-            <a:pPr algn="ctr" indent="0" marL="0">
+            <a:pPr marL="0" indent="0" algn="ctr">
               <a:buNone/>
             </a:pPr>
             <a:r>
@@ -5756,7 +5745,7 @@
           <a:bodyPr wrap="square" rtlCol="0" anchor="ctr"/>
           <a:lstStyle/>
           <a:p>
-            <a:pPr indent="0" marL="0">
+            <a:pPr marL="0" indent="0">
               <a:buNone/>
             </a:pPr>
             <a:r>
@@ -5795,7 +5784,7 @@
           <a:bodyPr wrap="square" rtlCol="0" anchor="ctr"/>
           <a:lstStyle/>
           <a:p>
-            <a:pPr indent="0" marL="0">
+            <a:pPr marL="0" indent="0">
               <a:buNone/>
             </a:pPr>
             <a:r>
@@ -5834,7 +5823,7 @@
           <a:bodyPr wrap="square" rtlCol="0" anchor="ctr"/>
           <a:lstStyle/>
           <a:p>
-            <a:pPr algn="r" indent="0" marL="0">
+            <a:pPr marL="0" indent="0" algn="r">
               <a:buNone/>
             </a:pPr>
             <a:r>
@@ -5896,6 +5885,13 @@
           </a:solidFill>
           <a:ln/>
         </p:spPr>
+        <p:txBody>
+          <a:bodyPr/>
+          <a:lstStyle/>
+          <a:p>
+            <a:endParaRPr lang="en-IN"/>
+          </a:p>
+        </p:txBody>
       </p:sp>
       <p:sp>
         <p:nvSpPr>
@@ -5918,7 +5914,7 @@
           <a:bodyPr wrap="square" rtlCol="0" anchor="ctr"/>
           <a:lstStyle/>
           <a:p>
-            <a:pPr indent="0" marL="0">
+            <a:pPr marL="0" indent="0">
               <a:buNone/>
             </a:pPr>
             <a:r>
@@ -5957,7 +5953,7 @@
           <a:bodyPr wrap="square" rtlCol="0" anchor="ctr"/>
           <a:lstStyle/>
           <a:p>
-            <a:pPr indent="0" marL="0">
+            <a:pPr marL="0" indent="0">
               <a:buNone/>
             </a:pPr>
             <a:r>
@@ -5994,6 +5990,13 @@
           </a:solidFill>
           <a:ln/>
         </p:spPr>
+        <p:txBody>
+          <a:bodyPr/>
+          <a:lstStyle/>
+          <a:p>
+            <a:endParaRPr lang="en-IN"/>
+          </a:p>
+        </p:txBody>
       </p:sp>
       <p:sp>
         <p:nvSpPr>
@@ -6016,7 +6019,7 @@
           <a:bodyPr wrap="square" rtlCol="0" anchor="ctr"/>
           <a:lstStyle/>
           <a:p>
-            <a:pPr indent="0" marL="0">
+            <a:pPr marL="0" indent="0">
               <a:buNone/>
             </a:pPr>
             <a:r>
@@ -6055,7 +6058,7 @@
           <a:bodyPr wrap="square" rtlCol="0" anchor="ctr"/>
           <a:lstStyle/>
           <a:p>
-            <a:pPr indent="0" marL="0">
+            <a:pPr marL="0" indent="0">
               <a:buNone/>
             </a:pPr>
             <a:r>
@@ -6094,7 +6097,7 @@
           <a:bodyPr wrap="square" rtlCol="0" anchor="ctr"/>
           <a:lstStyle/>
           <a:p>
-            <a:pPr indent="0" marL="0">
+            <a:pPr marL="0" indent="0">
               <a:buNone/>
             </a:pPr>
             <a:r>
@@ -6133,7 +6136,7 @@
           <a:bodyPr wrap="square" rtlCol="0" anchor="ctr"/>
           <a:lstStyle/>
           <a:p>
-            <a:pPr algn="ctr" indent="0" marL="0">
+            <a:pPr marL="0" indent="0" algn="ctr">
               <a:buNone/>
             </a:pPr>
             <a:r>
@@ -6170,6 +6173,13 @@
           </a:solidFill>
           <a:ln/>
         </p:spPr>
+        <p:txBody>
+          <a:bodyPr/>
+          <a:lstStyle/>
+          <a:p>
+            <a:endParaRPr lang="en-IN"/>
+          </a:p>
+        </p:txBody>
       </p:sp>
       <p:sp>
         <p:nvSpPr>
@@ -6192,7 +6202,7 @@
           <a:bodyPr wrap="square" rtlCol="0" anchor="ctr"/>
           <a:lstStyle/>
           <a:p>
-            <a:pPr indent="0" marL="0">
+            <a:pPr marL="0" indent="0">
               <a:buNone/>
             </a:pPr>
             <a:r>
@@ -6231,7 +6241,7 @@
           <a:bodyPr wrap="square" rtlCol="0" anchor="ctr"/>
           <a:lstStyle/>
           <a:p>
-            <a:pPr indent="0" marL="0">
+            <a:pPr marL="0" indent="0">
               <a:buNone/>
             </a:pPr>
             <a:r>
@@ -6270,7 +6280,7 @@
           <a:bodyPr wrap="square" rtlCol="0" anchor="ctr"/>
           <a:lstStyle/>
           <a:p>
-            <a:pPr indent="0" marL="0">
+            <a:pPr marL="0" indent="0">
               <a:buNone/>
             </a:pPr>
             <a:r>
@@ -6309,7 +6319,7 @@
           <a:bodyPr wrap="square" rtlCol="0" anchor="ctr"/>
           <a:lstStyle/>
           <a:p>
-            <a:pPr algn="ctr" indent="0" marL="0">
+            <a:pPr marL="0" indent="0" algn="ctr">
               <a:buNone/>
             </a:pPr>
             <a:r>
@@ -6346,6 +6356,13 @@
           </a:solidFill>
           <a:ln/>
         </p:spPr>
+        <p:txBody>
+          <a:bodyPr/>
+          <a:lstStyle/>
+          <a:p>
+            <a:endParaRPr lang="en-IN"/>
+          </a:p>
+        </p:txBody>
       </p:sp>
       <p:sp>
         <p:nvSpPr>
@@ -6368,7 +6385,7 @@
           <a:bodyPr wrap="square" rtlCol="0" anchor="ctr"/>
           <a:lstStyle/>
           <a:p>
-            <a:pPr indent="0" marL="0">
+            <a:pPr marL="0" indent="0">
               <a:buNone/>
             </a:pPr>
             <a:r>
@@ -6407,7 +6424,7 @@
           <a:bodyPr wrap="square" rtlCol="0" anchor="ctr"/>
           <a:lstStyle/>
           <a:p>
-            <a:pPr indent="0" marL="0">
+            <a:pPr marL="0" indent="0">
               <a:buNone/>
             </a:pPr>
             <a:r>
@@ -6446,7 +6463,7 @@
           <a:bodyPr wrap="square" rtlCol="0" anchor="ctr"/>
           <a:lstStyle/>
           <a:p>
-            <a:pPr indent="0" marL="0">
+            <a:pPr marL="0" indent="0">
               <a:buNone/>
             </a:pPr>
             <a:r>
@@ -6485,7 +6502,7 @@
           <a:bodyPr wrap="square" rtlCol="0" anchor="ctr"/>
           <a:lstStyle/>
           <a:p>
-            <a:pPr algn="ctr" indent="0" marL="0">
+            <a:pPr marL="0" indent="0" algn="ctr">
               <a:buNone/>
             </a:pPr>
             <a:r>
@@ -6522,6 +6539,13 @@
           </a:solidFill>
           <a:ln/>
         </p:spPr>
+        <p:txBody>
+          <a:bodyPr/>
+          <a:lstStyle/>
+          <a:p>
+            <a:endParaRPr lang="en-IN"/>
+          </a:p>
+        </p:txBody>
       </p:sp>
       <p:sp>
         <p:nvSpPr>
@@ -6544,7 +6568,7 @@
           <a:bodyPr wrap="square" rtlCol="0" anchor="ctr"/>
           <a:lstStyle/>
           <a:p>
-            <a:pPr indent="0" marL="0">
+            <a:pPr marL="0" indent="0">
               <a:buNone/>
             </a:pPr>
             <a:r>
@@ -6583,7 +6607,7 @@
           <a:bodyPr wrap="square" rtlCol="0" anchor="ctr"/>
           <a:lstStyle/>
           <a:p>
-            <a:pPr indent="0" marL="0">
+            <a:pPr marL="0" indent="0">
               <a:buNone/>
             </a:pPr>
             <a:r>
@@ -6622,7 +6646,7 @@
           <a:bodyPr wrap="square" rtlCol="0" anchor="ctr"/>
           <a:lstStyle/>
           <a:p>
-            <a:pPr indent="0" marL="0">
+            <a:pPr marL="0" indent="0">
               <a:buNone/>
             </a:pPr>
             <a:r>
@@ -6661,7 +6685,7 @@
           <a:bodyPr wrap="square" rtlCol="0" anchor="ctr"/>
           <a:lstStyle/>
           <a:p>
-            <a:pPr algn="ctr" indent="0" marL="0">
+            <a:pPr marL="0" indent="0" algn="ctr">
               <a:buNone/>
             </a:pPr>
             <a:r>
@@ -6698,6 +6722,13 @@
           </a:solidFill>
           <a:ln/>
         </p:spPr>
+        <p:txBody>
+          <a:bodyPr/>
+          <a:lstStyle/>
+          <a:p>
+            <a:endParaRPr lang="en-IN"/>
+          </a:p>
+        </p:txBody>
       </p:sp>
       <p:sp>
         <p:nvSpPr>
@@ -6720,7 +6751,7 @@
           <a:bodyPr wrap="square" rtlCol="0" anchor="ctr"/>
           <a:lstStyle/>
           <a:p>
-            <a:pPr indent="0" marL="0">
+            <a:pPr marL="0" indent="0">
               <a:buNone/>
             </a:pPr>
             <a:r>
@@ -6759,7 +6790,7 @@
           <a:bodyPr wrap="square" rtlCol="0" anchor="ctr"/>
           <a:lstStyle/>
           <a:p>
-            <a:pPr indent="0" marL="0">
+            <a:pPr marL="0" indent="0">
               <a:buNone/>
             </a:pPr>
             <a:r>
@@ -6798,7 +6829,7 @@
           <a:bodyPr wrap="square" rtlCol="0" anchor="ctr"/>
           <a:lstStyle/>
           <a:p>
-            <a:pPr indent="0" marL="0">
+            <a:pPr marL="0" indent="0">
               <a:buNone/>
             </a:pPr>
             <a:r>
@@ -6837,7 +6868,7 @@
           <a:bodyPr wrap="square" rtlCol="0" anchor="ctr"/>
           <a:lstStyle/>
           <a:p>
-            <a:pPr algn="ctr" indent="0" marL="0">
+            <a:pPr marL="0" indent="0" algn="ctr">
               <a:buNone/>
             </a:pPr>
             <a:r>
@@ -6874,6 +6905,13 @@
           </a:solidFill>
           <a:ln/>
         </p:spPr>
+        <p:txBody>
+          <a:bodyPr/>
+          <a:lstStyle/>
+          <a:p>
+            <a:endParaRPr lang="en-IN"/>
+          </a:p>
+        </p:txBody>
       </p:sp>
       <p:sp>
         <p:nvSpPr>
@@ -6896,7 +6934,7 @@
           <a:bodyPr wrap="square" rtlCol="0" anchor="ctr"/>
           <a:lstStyle/>
           <a:p>
-            <a:pPr indent="0" marL="0">
+            <a:pPr marL="0" indent="0">
               <a:buNone/>
             </a:pPr>
             <a:r>
@@ -6935,7 +6973,7 @@
           <a:bodyPr wrap="square" rtlCol="0" anchor="ctr"/>
           <a:lstStyle/>
           <a:p>
-            <a:pPr indent="0" marL="0">
+            <a:pPr marL="0" indent="0">
               <a:buNone/>
             </a:pPr>
             <a:r>
@@ -6974,7 +7012,7 @@
           <a:bodyPr wrap="square" rtlCol="0" anchor="ctr"/>
           <a:lstStyle/>
           <a:p>
-            <a:pPr indent="0" marL="0">
+            <a:pPr marL="0" indent="0">
               <a:buNone/>
             </a:pPr>
             <a:r>
@@ -7013,7 +7051,7 @@
           <a:bodyPr wrap="square" rtlCol="0" anchor="ctr"/>
           <a:lstStyle/>
           <a:p>
-            <a:pPr algn="ctr" indent="0" marL="0">
+            <a:pPr marL="0" indent="0" algn="ctr">
               <a:buNone/>
             </a:pPr>
             <a:r>
@@ -7050,6 +7088,13 @@
           </a:solidFill>
           <a:ln/>
         </p:spPr>
+        <p:txBody>
+          <a:bodyPr/>
+          <a:lstStyle/>
+          <a:p>
+            <a:endParaRPr lang="en-IN"/>
+          </a:p>
+        </p:txBody>
       </p:sp>
       <p:sp>
         <p:nvSpPr>
@@ -7072,7 +7117,7 @@
           <a:bodyPr wrap="square" rtlCol="0" anchor="ctr"/>
           <a:lstStyle/>
           <a:p>
-            <a:pPr indent="0" marL="0">
+            <a:pPr marL="0" indent="0">
               <a:buNone/>
             </a:pPr>
             <a:r>
@@ -7111,7 +7156,7 @@
           <a:bodyPr wrap="square" rtlCol="0" anchor="ctr"/>
           <a:lstStyle/>
           <a:p>
-            <a:pPr indent="0" marL="0">
+            <a:pPr marL="0" indent="0">
               <a:buNone/>
             </a:pPr>
             <a:r>
@@ -7150,7 +7195,7 @@
           <a:bodyPr wrap="square" rtlCol="0" anchor="ctr"/>
           <a:lstStyle/>
           <a:p>
-            <a:pPr indent="0" marL="0">
+            <a:pPr marL="0" indent="0">
               <a:buNone/>
             </a:pPr>
             <a:r>
@@ -7189,7 +7234,7 @@
           <a:bodyPr wrap="square" rtlCol="0" anchor="ctr"/>
           <a:lstStyle/>
           <a:p>
-            <a:pPr algn="ctr" indent="0" marL="0">
+            <a:pPr marL="0" indent="0" algn="ctr">
               <a:buNone/>
             </a:pPr>
             <a:r>
@@ -7228,7 +7273,7 @@
           <a:bodyPr wrap="square" rtlCol="0" anchor="ctr"/>
           <a:lstStyle/>
           <a:p>
-            <a:pPr indent="0" marL="0">
+            <a:pPr marL="0" indent="0">
               <a:buNone/>
             </a:pPr>
             <a:r>
@@ -7290,6 +7335,13 @@
           </a:solidFill>
           <a:ln/>
         </p:spPr>
+        <p:txBody>
+          <a:bodyPr/>
+          <a:lstStyle/>
+          <a:p>
+            <a:endParaRPr lang="en-IN"/>
+          </a:p>
+        </p:txBody>
       </p:sp>
       <p:sp>
         <p:nvSpPr>
@@ -7312,7 +7364,7 @@
           <a:bodyPr wrap="square" rtlCol="0" anchor="ctr"/>
           <a:lstStyle/>
           <a:p>
-            <a:pPr indent="0" marL="0">
+            <a:pPr marL="0" indent="0">
               <a:buNone/>
             </a:pPr>
             <a:r>
@@ -7351,7 +7403,7 @@
           <a:bodyPr wrap="square" rtlCol="0" anchor="ctr"/>
           <a:lstStyle/>
           <a:p>
-            <a:pPr indent="0" marL="0">
+            <a:pPr marL="0" indent="0">
               <a:buNone/>
             </a:pPr>
             <a:r>
@@ -7390,6 +7442,13 @@
           </a:solidFill>
           <a:ln/>
         </p:spPr>
+        <p:txBody>
+          <a:bodyPr/>
+          <a:lstStyle/>
+          <a:p>
+            <a:endParaRPr lang="en-IN"/>
+          </a:p>
+        </p:txBody>
       </p:sp>
       <p:sp>
         <p:nvSpPr>
@@ -7412,6 +7471,13 @@
           </a:solidFill>
           <a:ln/>
         </p:spPr>
+        <p:txBody>
+          <a:bodyPr/>
+          <a:lstStyle/>
+          <a:p>
+            <a:endParaRPr lang="en-IN"/>
+          </a:p>
+        </p:txBody>
       </p:sp>
       <p:sp>
         <p:nvSpPr>
@@ -7434,7 +7500,7 @@
           <a:bodyPr wrap="square" rtlCol="0" anchor="ctr"/>
           <a:lstStyle/>
           <a:p>
-            <a:pPr indent="0" marL="0">
+            <a:pPr marL="0" indent="0">
               <a:buNone/>
             </a:pPr>
             <a:r>
@@ -7473,7 +7539,7 @@
           <a:bodyPr wrap="square" rtlCol="0" anchor="ctr"/>
           <a:lstStyle/>
           <a:p>
-            <a:pPr indent="0" marL="0">
+            <a:pPr marL="0" indent="0">
               <a:buNone/>
             </a:pPr>
             <a:r>
@@ -7512,7 +7578,7 @@
           <a:bodyPr wrap="square" rtlCol="0" anchor="ctr"/>
           <a:lstStyle/>
           <a:p>
-            <a:pPr indent="0" marL="0">
+            <a:pPr marL="0" indent="0">
               <a:lnSpc>
                 <a:spcPct val="120000"/>
               </a:lnSpc>
@@ -7554,6 +7620,13 @@
           </a:solidFill>
           <a:ln/>
         </p:spPr>
+        <p:txBody>
+          <a:bodyPr/>
+          <a:lstStyle/>
+          <a:p>
+            <a:endParaRPr lang="en-IN"/>
+          </a:p>
+        </p:txBody>
       </p:sp>
       <p:sp>
         <p:nvSpPr>
@@ -7576,6 +7649,13 @@
           </a:solidFill>
           <a:ln/>
         </p:spPr>
+        <p:txBody>
+          <a:bodyPr/>
+          <a:lstStyle/>
+          <a:p>
+            <a:endParaRPr lang="en-IN"/>
+          </a:p>
+        </p:txBody>
       </p:sp>
       <p:sp>
         <p:nvSpPr>
@@ -7598,7 +7678,7 @@
           <a:bodyPr wrap="square" rtlCol="0" anchor="ctr"/>
           <a:lstStyle/>
           <a:p>
-            <a:pPr indent="0" marL="0">
+            <a:pPr marL="0" indent="0">
               <a:buNone/>
             </a:pPr>
             <a:r>
@@ -7637,7 +7717,7 @@
           <a:bodyPr wrap="square" rtlCol="0" anchor="ctr"/>
           <a:lstStyle/>
           <a:p>
-            <a:pPr indent="0" marL="0">
+            <a:pPr marL="0" indent="0">
               <a:buNone/>
             </a:pPr>
             <a:r>
@@ -7676,7 +7756,7 @@
           <a:bodyPr wrap="square" rtlCol="0" anchor="ctr"/>
           <a:lstStyle/>
           <a:p>
-            <a:pPr indent="0" marL="0">
+            <a:pPr marL="0" indent="0">
               <a:lnSpc>
                 <a:spcPct val="120000"/>
               </a:lnSpc>
@@ -7718,6 +7798,13 @@
           </a:solidFill>
           <a:ln/>
         </p:spPr>
+        <p:txBody>
+          <a:bodyPr/>
+          <a:lstStyle/>
+          <a:p>
+            <a:endParaRPr lang="en-IN"/>
+          </a:p>
+        </p:txBody>
       </p:sp>
       <p:sp>
         <p:nvSpPr>
@@ -7740,6 +7827,13 @@
           </a:solidFill>
           <a:ln/>
         </p:spPr>
+        <p:txBody>
+          <a:bodyPr/>
+          <a:lstStyle/>
+          <a:p>
+            <a:endParaRPr lang="en-IN"/>
+          </a:p>
+        </p:txBody>
       </p:sp>
       <p:sp>
         <p:nvSpPr>
@@ -7762,7 +7856,7 @@
           <a:bodyPr wrap="square" rtlCol="0" anchor="ctr"/>
           <a:lstStyle/>
           <a:p>
-            <a:pPr indent="0" marL="0">
+            <a:pPr marL="0" indent="0">
               <a:buNone/>
             </a:pPr>
             <a:r>
@@ -7801,7 +7895,7 @@
           <a:bodyPr wrap="square" rtlCol="0" anchor="ctr"/>
           <a:lstStyle/>
           <a:p>
-            <a:pPr indent="0" marL="0">
+            <a:pPr marL="0" indent="0">
               <a:buNone/>
             </a:pPr>
             <a:r>
@@ -7840,7 +7934,7 @@
           <a:bodyPr wrap="square" rtlCol="0" anchor="ctr"/>
           <a:lstStyle/>
           <a:p>
-            <a:pPr indent="0" marL="0">
+            <a:pPr marL="0" indent="0">
               <a:lnSpc>
                 <a:spcPct val="120000"/>
               </a:lnSpc>
@@ -7882,6 +7976,13 @@
           </a:solidFill>
           <a:ln/>
         </p:spPr>
+        <p:txBody>
+          <a:bodyPr/>
+          <a:lstStyle/>
+          <a:p>
+            <a:endParaRPr lang="en-IN"/>
+          </a:p>
+        </p:txBody>
       </p:sp>
       <p:sp>
         <p:nvSpPr>
@@ -7904,6 +8005,13 @@
           </a:solidFill>
           <a:ln/>
         </p:spPr>
+        <p:txBody>
+          <a:bodyPr/>
+          <a:lstStyle/>
+          <a:p>
+            <a:endParaRPr lang="en-IN"/>
+          </a:p>
+        </p:txBody>
       </p:sp>
       <p:sp>
         <p:nvSpPr>
@@ -7926,7 +8034,7 @@
           <a:bodyPr wrap="square" rtlCol="0" anchor="ctr"/>
           <a:lstStyle/>
           <a:p>
-            <a:pPr indent="0" marL="0">
+            <a:pPr marL="0" indent="0">
               <a:buNone/>
             </a:pPr>
             <a:r>
@@ -7965,7 +8073,7 @@
           <a:bodyPr wrap="square" rtlCol="0" anchor="ctr"/>
           <a:lstStyle/>
           <a:p>
-            <a:pPr indent="0" marL="0">
+            <a:pPr marL="0" indent="0">
               <a:buNone/>
             </a:pPr>
             <a:r>
@@ -8004,7 +8112,7 @@
           <a:bodyPr wrap="square" rtlCol="0" anchor="ctr"/>
           <a:lstStyle/>
           <a:p>
-            <a:pPr indent="0" marL="0">
+            <a:pPr marL="0" indent="0">
               <a:lnSpc>
                 <a:spcPct val="120000"/>
               </a:lnSpc>
@@ -8046,7 +8154,7 @@
           <a:bodyPr wrap="square" rtlCol="0" anchor="ctr"/>
           <a:lstStyle/>
           <a:p>
-            <a:pPr indent="0" marL="0">
+            <a:pPr marL="0" indent="0">
               <a:buNone/>
             </a:pPr>
             <a:r>
@@ -8108,6 +8216,13 @@
           </a:solidFill>
           <a:ln/>
         </p:spPr>
+        <p:txBody>
+          <a:bodyPr/>
+          <a:lstStyle/>
+          <a:p>
+            <a:endParaRPr lang="en-IN"/>
+          </a:p>
+        </p:txBody>
       </p:sp>
       <p:sp>
         <p:nvSpPr>
@@ -8130,7 +8245,7 @@
           <a:bodyPr wrap="square" rtlCol="0" anchor="ctr"/>
           <a:lstStyle/>
           <a:p>
-            <a:pPr indent="0" marL="0">
+            <a:pPr marL="0" indent="0">
               <a:buNone/>
             </a:pPr>
             <a:r>
@@ -8169,6 +8284,13 @@
           </a:solidFill>
           <a:ln/>
         </p:spPr>
+        <p:txBody>
+          <a:bodyPr/>
+          <a:lstStyle/>
+          <a:p>
+            <a:endParaRPr lang="en-IN"/>
+          </a:p>
+        </p:txBody>
       </p:sp>
       <p:sp>
         <p:nvSpPr>
@@ -8191,7 +8313,7 @@
           <a:bodyPr wrap="square" rtlCol="0" anchor="ctr"/>
           <a:lstStyle/>
           <a:p>
-            <a:pPr indent="0" marL="0">
+            <a:pPr marL="0" indent="0">
               <a:buNone/>
             </a:pPr>
             <a:r>
@@ -8230,7 +8352,7 @@
           <a:bodyPr wrap="square" rtlCol="0" anchor="ctr"/>
           <a:lstStyle/>
           <a:p>
-            <a:pPr indent="0" marL="0">
+            <a:pPr marL="0" indent="0">
               <a:lnSpc>
                 <a:spcPct val="135000"/>
               </a:lnSpc>
@@ -8250,7 +8372,7 @@
             <a:endParaRPr lang="en-US" sz="1050" dirty="0"/>
           </a:p>
           <a:p>
-            <a:pPr indent="0" marL="0">
+            <a:pPr marL="0" indent="0">
               <a:lnSpc>
                 <a:spcPct val="135000"/>
               </a:lnSpc>
@@ -8270,7 +8392,7 @@
             <a:endParaRPr lang="en-US" sz="1050" dirty="0"/>
           </a:p>
           <a:p>
-            <a:pPr indent="0" marL="0">
+            <a:pPr marL="0" indent="0">
               <a:lnSpc>
                 <a:spcPct val="135000"/>
               </a:lnSpc>
@@ -8312,6 +8434,13 @@
           </a:solidFill>
           <a:ln/>
         </p:spPr>
+        <p:txBody>
+          <a:bodyPr/>
+          <a:lstStyle/>
+          <a:p>
+            <a:endParaRPr lang="en-IN"/>
+          </a:p>
+        </p:txBody>
       </p:sp>
       <p:sp>
         <p:nvSpPr>
@@ -8334,7 +8463,7 @@
           <a:bodyPr wrap="square" rtlCol="0" anchor="ctr"/>
           <a:lstStyle/>
           <a:p>
-            <a:pPr indent="0" marL="0">
+            <a:pPr marL="0" indent="0">
               <a:buNone/>
             </a:pPr>
             <a:r>
@@ -8373,7 +8502,7 @@
           <a:bodyPr wrap="square" rtlCol="0" anchor="ctr"/>
           <a:lstStyle/>
           <a:p>
-            <a:pPr indent="0" marL="0">
+            <a:pPr marL="0" indent="0">
               <a:lnSpc>
                 <a:spcPct val="135000"/>
               </a:lnSpc>
@@ -8393,7 +8522,7 @@
             <a:endParaRPr lang="en-US" sz="1050" dirty="0"/>
           </a:p>
           <a:p>
-            <a:pPr indent="0" marL="0">
+            <a:pPr marL="0" indent="0">
               <a:lnSpc>
                 <a:spcPct val="135000"/>
               </a:lnSpc>
@@ -8413,7 +8542,7 @@
             <a:endParaRPr lang="en-US" sz="1050" dirty="0"/>
           </a:p>
           <a:p>
-            <a:pPr indent="0" marL="0">
+            <a:pPr marL="0" indent="0">
               <a:lnSpc>
                 <a:spcPct val="135000"/>
               </a:lnSpc>
@@ -8455,6 +8584,13 @@
           </a:solidFill>
           <a:ln/>
         </p:spPr>
+        <p:txBody>
+          <a:bodyPr/>
+          <a:lstStyle/>
+          <a:p>
+            <a:endParaRPr lang="en-IN"/>
+          </a:p>
+        </p:txBody>
       </p:sp>
       <p:sp>
         <p:nvSpPr>
@@ -8477,7 +8613,7 @@
           <a:bodyPr wrap="square" rtlCol="0" anchor="ctr"/>
           <a:lstStyle/>
           <a:p>
-            <a:pPr indent="0" marL="0">
+            <a:pPr marL="0" indent="0">
               <a:buNone/>
             </a:pPr>
             <a:r>
@@ -8516,7 +8652,7 @@
           <a:bodyPr wrap="square" rtlCol="0" anchor="ctr"/>
           <a:lstStyle/>
           <a:p>
-            <a:pPr indent="0" marL="0">
+            <a:pPr marL="0" indent="0">
               <a:lnSpc>
                 <a:spcPct val="130000"/>
               </a:lnSpc>
@@ -8536,7 +8672,7 @@
             <a:endParaRPr lang="en-US" sz="1050" dirty="0"/>
           </a:p>
           <a:p>
-            <a:pPr indent="0" marL="0">
+            <a:pPr marL="0" indent="0">
               <a:lnSpc>
                 <a:spcPct val="130000"/>
               </a:lnSpc>
@@ -8556,7 +8692,7 @@
             <a:endParaRPr lang="en-US" sz="1050" dirty="0"/>
           </a:p>
           <a:p>
-            <a:pPr indent="0" marL="0">
+            <a:pPr marL="0" indent="0">
               <a:lnSpc>
                 <a:spcPct val="130000"/>
               </a:lnSpc>
@@ -8576,7 +8712,7 @@
             <a:endParaRPr lang="en-US" sz="1050" dirty="0"/>
           </a:p>
           <a:p>
-            <a:pPr indent="0" marL="0">
+            <a:pPr marL="0" indent="0">
               <a:lnSpc>
                 <a:spcPct val="130000"/>
               </a:lnSpc>
@@ -8618,6 +8754,13 @@
           </a:solidFill>
           <a:ln/>
         </p:spPr>
+        <p:txBody>
+          <a:bodyPr/>
+          <a:lstStyle/>
+          <a:p>
+            <a:endParaRPr lang="en-IN"/>
+          </a:p>
+        </p:txBody>
       </p:sp>
       <p:sp>
         <p:nvSpPr>
@@ -8640,7 +8783,7 @@
           <a:bodyPr wrap="square" rtlCol="0" anchor="ctr"/>
           <a:lstStyle/>
           <a:p>
-            <a:pPr indent="0" marL="0">
+            <a:pPr marL="0" indent="0">
               <a:buNone/>
             </a:pPr>
             <a:r>
@@ -8679,7 +8822,7 @@
           <a:bodyPr wrap="square" rtlCol="0" anchor="ctr"/>
           <a:lstStyle/>
           <a:p>
-            <a:pPr indent="0" marL="0">
+            <a:pPr marL="0" indent="0">
               <a:lnSpc>
                 <a:spcPct val="130000"/>
               </a:lnSpc>
@@ -8699,7 +8842,7 @@
             <a:endParaRPr lang="en-US" sz="1050" dirty="0"/>
           </a:p>
           <a:p>
-            <a:pPr indent="0" marL="0">
+            <a:pPr marL="0" indent="0">
               <a:lnSpc>
                 <a:spcPct val="130000"/>
               </a:lnSpc>
@@ -8719,7 +8862,7 @@
             <a:endParaRPr lang="en-US" sz="1050" dirty="0"/>
           </a:p>
           <a:p>
-            <a:pPr indent="0" marL="0">
+            <a:pPr marL="0" indent="0">
               <a:lnSpc>
                 <a:spcPct val="130000"/>
               </a:lnSpc>
@@ -8739,7 +8882,7 @@
             <a:endParaRPr lang="en-US" sz="1050" dirty="0"/>
           </a:p>
           <a:p>
-            <a:pPr indent="0" marL="0">
+            <a:pPr marL="0" indent="0">
               <a:lnSpc>
                 <a:spcPct val="130000"/>
               </a:lnSpc>
@@ -8781,7 +8924,7 @@
           <a:bodyPr wrap="square" rtlCol="0" anchor="ctr"/>
           <a:lstStyle/>
           <a:p>
-            <a:pPr algn="ctr" indent="0" marL="0">
+            <a:pPr marL="0" indent="0" algn="ctr">
               <a:buNone/>
             </a:pPr>
             <a:r>
@@ -8843,6 +8986,13 @@
           </a:solidFill>
           <a:ln/>
         </p:spPr>
+        <p:txBody>
+          <a:bodyPr/>
+          <a:lstStyle/>
+          <a:p>
+            <a:endParaRPr lang="en-IN"/>
+          </a:p>
+        </p:txBody>
       </p:sp>
       <p:sp>
         <p:nvSpPr>
@@ -8865,7 +9015,7 @@
           <a:bodyPr wrap="square" rtlCol="0" anchor="ctr"/>
           <a:lstStyle/>
           <a:p>
-            <a:pPr indent="0" marL="0">
+            <a:pPr marL="0" indent="0">
               <a:buNone/>
             </a:pPr>
             <a:r>
@@ -8904,7 +9054,7 @@
           <a:bodyPr wrap="square" rtlCol="0" anchor="ctr"/>
           <a:lstStyle/>
           <a:p>
-            <a:pPr indent="0" marL="0">
+            <a:pPr marL="0" indent="0">
               <a:buNone/>
             </a:pPr>
             <a:r>
@@ -8941,6 +9091,13 @@
           </a:solidFill>
           <a:ln/>
         </p:spPr>
+        <p:txBody>
+          <a:bodyPr/>
+          <a:lstStyle/>
+          <a:p>
+            <a:endParaRPr lang="en-IN"/>
+          </a:p>
+        </p:txBody>
       </p:sp>
       <p:sp>
         <p:nvSpPr>
@@ -8963,7 +9120,7 @@
           <a:bodyPr wrap="square" rtlCol="0" anchor="ctr"/>
           <a:lstStyle/>
           <a:p>
-            <a:pPr indent="0" marL="0">
+            <a:pPr marL="0" indent="0">
               <a:buNone/>
             </a:pPr>
             <a:r>
@@ -9002,7 +9159,7 @@
           <a:bodyPr wrap="square" rtlCol="0" anchor="ctr"/>
           <a:lstStyle/>
           <a:p>
-            <a:pPr indent="0" marL="0">
+            <a:pPr marL="0" indent="0">
               <a:buNone/>
             </a:pPr>
             <a:r>
@@ -9041,7 +9198,7 @@
           <a:bodyPr wrap="square" rtlCol="0" anchor="ctr"/>
           <a:lstStyle/>
           <a:p>
-            <a:pPr indent="0" marL="0">
+            <a:pPr marL="0" indent="0">
               <a:buNone/>
             </a:pPr>
             <a:r>
@@ -9078,6 +9235,13 @@
           </a:solidFill>
           <a:ln/>
         </p:spPr>
+        <p:txBody>
+          <a:bodyPr/>
+          <a:lstStyle/>
+          <a:p>
+            <a:endParaRPr lang="en-IN"/>
+          </a:p>
+        </p:txBody>
       </p:sp>
       <p:sp>
         <p:nvSpPr>
@@ -9100,7 +9264,7 @@
           <a:bodyPr wrap="square" rtlCol="0" anchor="ctr"/>
           <a:lstStyle/>
           <a:p>
-            <a:pPr indent="0" marL="0">
+            <a:pPr marL="0" indent="0">
               <a:buNone/>
             </a:pPr>
             <a:r>
@@ -9139,7 +9303,7 @@
           <a:bodyPr wrap="square" rtlCol="0" anchor="ctr"/>
           <a:lstStyle/>
           <a:p>
-            <a:pPr indent="0" marL="0">
+            <a:pPr marL="0" indent="0">
               <a:buNone/>
             </a:pPr>
             <a:r>
@@ -9178,7 +9342,7 @@
           <a:bodyPr wrap="square" rtlCol="0" anchor="ctr"/>
           <a:lstStyle/>
           <a:p>
-            <a:pPr indent="0" marL="0">
+            <a:pPr marL="0" indent="0">
               <a:buNone/>
             </a:pPr>
             <a:r>
@@ -9215,6 +9379,13 @@
           </a:solidFill>
           <a:ln/>
         </p:spPr>
+        <p:txBody>
+          <a:bodyPr/>
+          <a:lstStyle/>
+          <a:p>
+            <a:endParaRPr lang="en-IN"/>
+          </a:p>
+        </p:txBody>
       </p:sp>
       <p:sp>
         <p:nvSpPr>
@@ -9237,7 +9408,7 @@
           <a:bodyPr wrap="square" rtlCol="0" anchor="ctr"/>
           <a:lstStyle/>
           <a:p>
-            <a:pPr indent="0" marL="0">
+            <a:pPr marL="0" indent="0">
               <a:buNone/>
             </a:pPr>
             <a:r>
@@ -9276,7 +9447,7 @@
           <a:bodyPr wrap="square" rtlCol="0" anchor="ctr"/>
           <a:lstStyle/>
           <a:p>
-            <a:pPr indent="0" marL="0">
+            <a:pPr marL="0" indent="0">
               <a:buNone/>
             </a:pPr>
             <a:r>
@@ -9315,7 +9486,7 @@
           <a:bodyPr wrap="square" rtlCol="0" anchor="ctr"/>
           <a:lstStyle/>
           <a:p>
-            <a:pPr indent="0" marL="0">
+            <a:pPr marL="0" indent="0">
               <a:buNone/>
             </a:pPr>
             <a:r>
@@ -9352,6 +9523,13 @@
           </a:solidFill>
           <a:ln/>
         </p:spPr>
+        <p:txBody>
+          <a:bodyPr/>
+          <a:lstStyle/>
+          <a:p>
+            <a:endParaRPr lang="en-IN"/>
+          </a:p>
+        </p:txBody>
       </p:sp>
       <p:sp>
         <p:nvSpPr>
@@ -9374,7 +9552,7 @@
           <a:bodyPr wrap="square" rtlCol="0" anchor="ctr"/>
           <a:lstStyle/>
           <a:p>
-            <a:pPr indent="0" marL="0">
+            <a:pPr marL="0" indent="0">
               <a:buNone/>
             </a:pPr>
             <a:r>
@@ -9413,7 +9591,7 @@
           <a:bodyPr wrap="square" rtlCol="0" anchor="ctr"/>
           <a:lstStyle/>
           <a:p>
-            <a:pPr indent="0" marL="0">
+            <a:pPr marL="0" indent="0">
               <a:buNone/>
             </a:pPr>
             <a:r>
@@ -9452,7 +9630,7 @@
           <a:bodyPr wrap="square" rtlCol="0" anchor="ctr"/>
           <a:lstStyle/>
           <a:p>
-            <a:pPr indent="0" marL="0">
+            <a:pPr marL="0" indent="0">
               <a:buNone/>
             </a:pPr>
             <a:r>
@@ -9489,6 +9667,13 @@
           </a:solidFill>
           <a:ln/>
         </p:spPr>
+        <p:txBody>
+          <a:bodyPr/>
+          <a:lstStyle/>
+          <a:p>
+            <a:endParaRPr lang="en-IN"/>
+          </a:p>
+        </p:txBody>
       </p:sp>
       <p:sp>
         <p:nvSpPr>
@@ -9511,7 +9696,7 @@
           <a:bodyPr wrap="square" rtlCol="0" anchor="ctr"/>
           <a:lstStyle/>
           <a:p>
-            <a:pPr indent="0" marL="0">
+            <a:pPr marL="0" indent="0">
               <a:buNone/>
             </a:pPr>
             <a:r>
@@ -9550,7 +9735,7 @@
           <a:bodyPr wrap="square" rtlCol="0" anchor="ctr"/>
           <a:lstStyle/>
           <a:p>
-            <a:pPr indent="0" marL="0">
+            <a:pPr marL="0" indent="0">
               <a:buNone/>
             </a:pPr>
             <a:r>
@@ -9589,7 +9774,7 @@
           <a:bodyPr wrap="square" rtlCol="0" anchor="ctr"/>
           <a:lstStyle/>
           <a:p>
-            <a:pPr indent="0" marL="0">
+            <a:pPr marL="0" indent="0">
               <a:buNone/>
             </a:pPr>
             <a:r>
@@ -9626,6 +9811,13 @@
           </a:solidFill>
           <a:ln/>
         </p:spPr>
+        <p:txBody>
+          <a:bodyPr/>
+          <a:lstStyle/>
+          <a:p>
+            <a:endParaRPr lang="en-IN"/>
+          </a:p>
+        </p:txBody>
       </p:sp>
       <p:sp>
         <p:nvSpPr>
@@ -9648,7 +9840,7 @@
           <a:bodyPr wrap="square" rtlCol="0" anchor="ctr"/>
           <a:lstStyle/>
           <a:p>
-            <a:pPr indent="0" marL="0">
+            <a:pPr marL="0" indent="0">
               <a:buNone/>
             </a:pPr>
             <a:r>
@@ -9687,7 +9879,7 @@
           <a:bodyPr wrap="square" rtlCol="0" anchor="ctr"/>
           <a:lstStyle/>
           <a:p>
-            <a:pPr indent="0" marL="0">
+            <a:pPr marL="0" indent="0">
               <a:buNone/>
             </a:pPr>
             <a:r>
@@ -9726,7 +9918,7 @@
           <a:bodyPr wrap="square" rtlCol="0" anchor="ctr"/>
           <a:lstStyle/>
           <a:p>
-            <a:pPr indent="0" marL="0">
+            <a:pPr marL="0" indent="0">
               <a:buNone/>
             </a:pPr>
             <a:r>
@@ -9763,6 +9955,13 @@
           </a:solidFill>
           <a:ln/>
         </p:spPr>
+        <p:txBody>
+          <a:bodyPr/>
+          <a:lstStyle/>
+          <a:p>
+            <a:endParaRPr lang="en-IN"/>
+          </a:p>
+        </p:txBody>
       </p:sp>
       <p:sp>
         <p:nvSpPr>
@@ -9785,7 +9984,7 @@
           <a:bodyPr wrap="square" rtlCol="0" anchor="ctr"/>
           <a:lstStyle/>
           <a:p>
-            <a:pPr indent="0" marL="0">
+            <a:pPr marL="0" indent="0">
               <a:buNone/>
             </a:pPr>
             <a:r>
@@ -9824,7 +10023,7 @@
           <a:bodyPr wrap="square" rtlCol="0" anchor="ctr"/>
           <a:lstStyle/>
           <a:p>
-            <a:pPr indent="0" marL="0">
+            <a:pPr marL="0" indent="0">
               <a:buNone/>
             </a:pPr>
             <a:r>
@@ -9863,7 +10062,7 @@
           <a:bodyPr wrap="square" rtlCol="0" anchor="ctr"/>
           <a:lstStyle/>
           <a:p>
-            <a:pPr indent="0" marL="0">
+            <a:pPr marL="0" indent="0">
               <a:buNone/>
             </a:pPr>
             <a:r>
@@ -9900,6 +10099,13 @@
           </a:solidFill>
           <a:ln/>
         </p:spPr>
+        <p:txBody>
+          <a:bodyPr/>
+          <a:lstStyle/>
+          <a:p>
+            <a:endParaRPr lang="en-IN"/>
+          </a:p>
+        </p:txBody>
       </p:sp>
       <p:sp>
         <p:nvSpPr>
@@ -9922,7 +10128,7 @@
           <a:bodyPr wrap="square" rtlCol="0" anchor="ctr"/>
           <a:lstStyle/>
           <a:p>
-            <a:pPr indent="0" marL="0">
+            <a:pPr marL="0" indent="0">
               <a:buNone/>
             </a:pPr>
             <a:r>
@@ -9961,7 +10167,7 @@
           <a:bodyPr wrap="square" rtlCol="0" anchor="ctr"/>
           <a:lstStyle/>
           <a:p>
-            <a:pPr indent="0" marL="0">
+            <a:pPr marL="0" indent="0">
               <a:buNone/>
             </a:pPr>
             <a:r>
@@ -10000,7 +10206,7 @@
           <a:bodyPr wrap="square" rtlCol="0" anchor="ctr"/>
           <a:lstStyle/>
           <a:p>
-            <a:pPr indent="0" marL="0">
+            <a:pPr marL="0" indent="0">
               <a:buNone/>
             </a:pPr>
             <a:r>
@@ -10037,6 +10243,13 @@
           </a:solidFill>
           <a:ln/>
         </p:spPr>
+        <p:txBody>
+          <a:bodyPr/>
+          <a:lstStyle/>
+          <a:p>
+            <a:endParaRPr lang="en-IN"/>
+          </a:p>
+        </p:txBody>
       </p:sp>
       <p:sp>
         <p:nvSpPr>
@@ -10059,7 +10272,7 @@
           <a:bodyPr wrap="square" rtlCol="0" anchor="ctr"/>
           <a:lstStyle/>
           <a:p>
-            <a:pPr indent="0" marL="0">
+            <a:pPr marL="0" indent="0">
               <a:buNone/>
             </a:pPr>
             <a:r>
@@ -10098,7 +10311,7 @@
           <a:bodyPr wrap="square" rtlCol="0" anchor="ctr"/>
           <a:lstStyle/>
           <a:p>
-            <a:pPr indent="0" marL="0">
+            <a:pPr marL="0" indent="0">
               <a:buNone/>
             </a:pPr>
             <a:r>
@@ -10137,7 +10350,7 @@
           <a:bodyPr wrap="square" rtlCol="0" anchor="ctr"/>
           <a:lstStyle/>
           <a:p>
-            <a:pPr indent="0" marL="0">
+            <a:pPr marL="0" indent="0">
               <a:buNone/>
             </a:pPr>
             <a:r>
@@ -10199,6 +10412,13 @@
           </a:solidFill>
           <a:ln/>
         </p:spPr>
+        <p:txBody>
+          <a:bodyPr/>
+          <a:lstStyle/>
+          <a:p>
+            <a:endParaRPr lang="en-IN"/>
+          </a:p>
+        </p:txBody>
       </p:sp>
       <p:sp>
         <p:nvSpPr>
@@ -10221,7 +10441,7 @@
           <a:bodyPr wrap="square" rtlCol="0" anchor="ctr"/>
           <a:lstStyle/>
           <a:p>
-            <a:pPr indent="0" marL="0">
+            <a:pPr marL="0" indent="0">
               <a:buNone/>
             </a:pPr>
             <a:r>
@@ -10260,7 +10480,7 @@
           <a:bodyPr wrap="square" rtlCol="0" anchor="ctr"/>
           <a:lstStyle/>
           <a:p>
-            <a:pPr indent="0" marL="0">
+            <a:pPr marL="0" indent="0">
               <a:buNone/>
             </a:pPr>
             <a:r>
@@ -10299,6 +10519,13 @@
           </a:solidFill>
           <a:ln/>
         </p:spPr>
+        <p:txBody>
+          <a:bodyPr/>
+          <a:lstStyle/>
+          <a:p>
+            <a:endParaRPr lang="en-IN"/>
+          </a:p>
+        </p:txBody>
       </p:sp>
       <p:sp>
         <p:nvSpPr>
@@ -10321,6 +10548,13 @@
           </a:solidFill>
           <a:ln/>
         </p:spPr>
+        <p:txBody>
+          <a:bodyPr/>
+          <a:lstStyle/>
+          <a:p>
+            <a:endParaRPr lang="en-IN"/>
+          </a:p>
+        </p:txBody>
       </p:sp>
       <p:sp>
         <p:nvSpPr>
@@ -10343,7 +10577,7 @@
           <a:bodyPr wrap="square" rtlCol="0" anchor="ctr"/>
           <a:lstStyle/>
           <a:p>
-            <a:pPr indent="0" marL="0">
+            <a:pPr marL="0" indent="0">
               <a:buNone/>
             </a:pPr>
             <a:r>
@@ -10382,7 +10616,7 @@
           <a:bodyPr wrap="square" rtlCol="0" anchor="ctr"/>
           <a:lstStyle/>
           <a:p>
-            <a:pPr indent="0" marL="0">
+            <a:pPr marL="0" indent="0">
               <a:buNone/>
             </a:pPr>
             <a:r>
@@ -10421,7 +10655,7 @@
           <a:bodyPr wrap="square" rtlCol="0" anchor="ctr"/>
           <a:lstStyle/>
           <a:p>
-            <a:pPr indent="0" marL="0">
+            <a:pPr marL="0" indent="0">
               <a:lnSpc>
                 <a:spcPct val="120000"/>
               </a:lnSpc>
@@ -10463,6 +10697,13 @@
           </a:solidFill>
           <a:ln/>
         </p:spPr>
+        <p:txBody>
+          <a:bodyPr/>
+          <a:lstStyle/>
+          <a:p>
+            <a:endParaRPr lang="en-IN"/>
+          </a:p>
+        </p:txBody>
       </p:sp>
       <p:sp>
         <p:nvSpPr>
@@ -10485,6 +10726,13 @@
           </a:solidFill>
           <a:ln/>
         </p:spPr>
+        <p:txBody>
+          <a:bodyPr/>
+          <a:lstStyle/>
+          <a:p>
+            <a:endParaRPr lang="en-IN"/>
+          </a:p>
+        </p:txBody>
       </p:sp>
       <p:sp>
         <p:nvSpPr>
@@ -10507,7 +10755,7 @@
           <a:bodyPr wrap="square" rtlCol="0" anchor="ctr"/>
           <a:lstStyle/>
           <a:p>
-            <a:pPr indent="0" marL="0">
+            <a:pPr marL="0" indent="0">
               <a:buNone/>
             </a:pPr>
             <a:r>
@@ -10546,7 +10794,7 @@
           <a:bodyPr wrap="square" rtlCol="0" anchor="ctr"/>
           <a:lstStyle/>
           <a:p>
-            <a:pPr indent="0" marL="0">
+            <a:pPr marL="0" indent="0">
               <a:buNone/>
             </a:pPr>
             <a:r>
@@ -10585,7 +10833,7 @@
           <a:bodyPr wrap="square" rtlCol="0" anchor="ctr"/>
           <a:lstStyle/>
           <a:p>
-            <a:pPr indent="0" marL="0">
+            <a:pPr marL="0" indent="0">
               <a:lnSpc>
                 <a:spcPct val="120000"/>
               </a:lnSpc>
@@ -10627,6 +10875,13 @@
           </a:solidFill>
           <a:ln/>
         </p:spPr>
+        <p:txBody>
+          <a:bodyPr/>
+          <a:lstStyle/>
+          <a:p>
+            <a:endParaRPr lang="en-IN"/>
+          </a:p>
+        </p:txBody>
       </p:sp>
       <p:sp>
         <p:nvSpPr>
@@ -10649,6 +10904,13 @@
           </a:solidFill>
           <a:ln/>
         </p:spPr>
+        <p:txBody>
+          <a:bodyPr/>
+          <a:lstStyle/>
+          <a:p>
+            <a:endParaRPr lang="en-IN"/>
+          </a:p>
+        </p:txBody>
       </p:sp>
       <p:sp>
         <p:nvSpPr>
@@ -10671,7 +10933,7 @@
           <a:bodyPr wrap="square" rtlCol="0" anchor="ctr"/>
           <a:lstStyle/>
           <a:p>
-            <a:pPr indent="0" marL="0">
+            <a:pPr marL="0" indent="0">
               <a:buNone/>
             </a:pPr>
             <a:r>
@@ -10710,7 +10972,7 @@
           <a:bodyPr wrap="square" rtlCol="0" anchor="ctr"/>
           <a:lstStyle/>
           <a:p>
-            <a:pPr indent="0" marL="0">
+            <a:pPr marL="0" indent="0">
               <a:buNone/>
             </a:pPr>
             <a:r>
@@ -10749,7 +11011,7 @@
           <a:bodyPr wrap="square" rtlCol="0" anchor="ctr"/>
           <a:lstStyle/>
           <a:p>
-            <a:pPr indent="0" marL="0">
+            <a:pPr marL="0" indent="0">
               <a:lnSpc>
                 <a:spcPct val="120000"/>
               </a:lnSpc>
@@ -10791,6 +11053,13 @@
           </a:solidFill>
           <a:ln/>
         </p:spPr>
+        <p:txBody>
+          <a:bodyPr/>
+          <a:lstStyle/>
+          <a:p>
+            <a:endParaRPr lang="en-IN"/>
+          </a:p>
+        </p:txBody>
       </p:sp>
       <p:sp>
         <p:nvSpPr>
@@ -10813,6 +11082,13 @@
           </a:solidFill>
           <a:ln/>
         </p:spPr>
+        <p:txBody>
+          <a:bodyPr/>
+          <a:lstStyle/>
+          <a:p>
+            <a:endParaRPr lang="en-IN"/>
+          </a:p>
+        </p:txBody>
       </p:sp>
       <p:sp>
         <p:nvSpPr>
@@ -10835,7 +11111,7 @@
           <a:bodyPr wrap="square" rtlCol="0" anchor="ctr"/>
           <a:lstStyle/>
           <a:p>
-            <a:pPr indent="0" marL="0">
+            <a:pPr marL="0" indent="0">
               <a:buNone/>
             </a:pPr>
             <a:r>
@@ -10874,7 +11150,7 @@
           <a:bodyPr wrap="square" rtlCol="0" anchor="ctr"/>
           <a:lstStyle/>
           <a:p>
-            <a:pPr indent="0" marL="0">
+            <a:pPr marL="0" indent="0">
               <a:buNone/>
             </a:pPr>
             <a:r>
@@ -10913,7 +11189,7 @@
           <a:bodyPr wrap="square" rtlCol="0" anchor="ctr"/>
           <a:lstStyle/>
           <a:p>
-            <a:pPr indent="0" marL="0">
+            <a:pPr marL="0" indent="0">
               <a:lnSpc>
                 <a:spcPct val="120000"/>
               </a:lnSpc>
@@ -10955,6 +11231,13 @@
           </a:solidFill>
           <a:ln/>
         </p:spPr>
+        <p:txBody>
+          <a:bodyPr/>
+          <a:lstStyle/>
+          <a:p>
+            <a:endParaRPr lang="en-IN"/>
+          </a:p>
+        </p:txBody>
       </p:sp>
       <p:sp>
         <p:nvSpPr>
@@ -10977,6 +11260,13 @@
           </a:solidFill>
           <a:ln/>
         </p:spPr>
+        <p:txBody>
+          <a:bodyPr/>
+          <a:lstStyle/>
+          <a:p>
+            <a:endParaRPr lang="en-IN"/>
+          </a:p>
+        </p:txBody>
       </p:sp>
       <p:sp>
         <p:nvSpPr>
@@ -10999,7 +11289,7 @@
           <a:bodyPr wrap="square" rtlCol="0" anchor="ctr"/>
           <a:lstStyle/>
           <a:p>
-            <a:pPr indent="0" marL="0">
+            <a:pPr marL="0" indent="0">
               <a:buNone/>
             </a:pPr>
             <a:r>
@@ -11038,7 +11328,7 @@
           <a:bodyPr wrap="square" rtlCol="0" anchor="ctr"/>
           <a:lstStyle/>
           <a:p>
-            <a:pPr indent="0" marL="0">
+            <a:pPr marL="0" indent="0">
               <a:buNone/>
             </a:pPr>
             <a:r>
@@ -11077,7 +11367,7 @@
           <a:bodyPr wrap="square" rtlCol="0" anchor="ctr"/>
           <a:lstStyle/>
           <a:p>
-            <a:pPr indent="0" marL="0">
+            <a:pPr marL="0" indent="0">
               <a:lnSpc>
                 <a:spcPct val="120000"/>
               </a:lnSpc>
@@ -11399,4 +11689,325 @@
     </a:ext>
   </a:extLst>
 </a:theme>
+</file>
+
+<file path=ppt/theme/theme2.xml><?xml version="1.0" encoding="utf-8"?>
+<a:theme xmlns:a="http://schemas.openxmlformats.org/drawingml/2006/main" name="Office Theme">
+  <a:themeElements>
+    <a:clrScheme name="Office">
+      <a:dk1>
+        <a:sysClr val="windowText" lastClr="000000"/>
+      </a:dk1>
+      <a:lt1>
+        <a:sysClr val="window" lastClr="FFFFFF"/>
+      </a:lt1>
+      <a:dk2>
+        <a:srgbClr val="0E2841"/>
+      </a:dk2>
+      <a:lt2>
+        <a:srgbClr val="E8E8E8"/>
+      </a:lt2>
+      <a:accent1>
+        <a:srgbClr val="156082"/>
+      </a:accent1>
+      <a:accent2>
+        <a:srgbClr val="E97132"/>
+      </a:accent2>
+      <a:accent3>
+        <a:srgbClr val="196B24"/>
+      </a:accent3>
+      <a:accent4>
+        <a:srgbClr val="0F9ED5"/>
+      </a:accent4>
+      <a:accent5>
+        <a:srgbClr val="A02B93"/>
+      </a:accent5>
+      <a:accent6>
+        <a:srgbClr val="4EA72E"/>
+      </a:accent6>
+      <a:hlink>
+        <a:srgbClr val="467886"/>
+      </a:hlink>
+      <a:folHlink>
+        <a:srgbClr val="96607D"/>
+      </a:folHlink>
+    </a:clrScheme>
+    <a:fontScheme name="Office">
+      <a:majorFont>
+        <a:latin typeface="Aptos Display" panose="02110004020202020204"/>
+        <a:ea typeface=""/>
+        <a:cs typeface=""/>
+        <a:font script="Jpan" typeface="游ゴシック Light"/>
+        <a:font script="Hang" typeface="맑은 고딕"/>
+        <a:font script="Hans" typeface="等线 Light"/>
+        <a:font script="Hant" typeface="新細明體"/>
+        <a:font script="Arab" typeface="Times New Roman"/>
+        <a:font script="Hebr" typeface="Times New Roman"/>
+        <a:font script="Thai" typeface="Angsana New"/>
+        <a:font script="Ethi" typeface="Nyala"/>
+        <a:font script="Beng" typeface="Vrinda"/>
+        <a:font script="Gujr" typeface="Shruti"/>
+        <a:font script="Khmr" typeface="MoolBoran"/>
+        <a:font script="Knda" typeface="Tunga"/>
+        <a:font script="Guru" typeface="Raavi"/>
+        <a:font script="Cans" typeface="Euphemia"/>
+        <a:font script="Cher" typeface="Plantagenet Cherokee"/>
+        <a:font script="Yiii" typeface="Microsoft Yi Baiti"/>
+        <a:font script="Tibt" typeface="Microsoft Himalaya"/>
+        <a:font script="Thaa" typeface="MV Boli"/>
+        <a:font script="Deva" typeface="Mangal"/>
+        <a:font script="Telu" typeface="Gautami"/>
+        <a:font script="Taml" typeface="Latha"/>
+        <a:font script="Syrc" typeface="Estrangelo Edessa"/>
+        <a:font script="Orya" typeface="Kalinga"/>
+        <a:font script="Mlym" typeface="Kartika"/>
+        <a:font script="Laoo" typeface="DokChampa"/>
+        <a:font script="Sinh" typeface="Iskoola Pota"/>
+        <a:font script="Mong" typeface="Mongolian Baiti"/>
+        <a:font script="Viet" typeface="Times New Roman"/>
+        <a:font script="Uigh" typeface="Microsoft Uighur"/>
+        <a:font script="Geor" typeface="Sylfaen"/>
+        <a:font script="Armn" typeface="Arial"/>
+        <a:font script="Bugi" typeface="Leelawadee UI"/>
+        <a:font script="Bopo" typeface="Microsoft JhengHei"/>
+        <a:font script="Java" typeface="Javanese Text"/>
+        <a:font script="Lisu" typeface="Segoe UI"/>
+        <a:font script="Mymr" typeface="Myanmar Text"/>
+        <a:font script="Nkoo" typeface="Ebrima"/>
+        <a:font script="Olck" typeface="Nirmala UI"/>
+        <a:font script="Osma" typeface="Ebrima"/>
+        <a:font script="Phag" typeface="Phagspa"/>
+        <a:font script="Syrn" typeface="Estrangelo Edessa"/>
+        <a:font script="Syrj" typeface="Estrangelo Edessa"/>
+        <a:font script="Syre" typeface="Estrangelo Edessa"/>
+        <a:font script="Sora" typeface="Nirmala UI"/>
+        <a:font script="Tale" typeface="Microsoft Tai Le"/>
+        <a:font script="Talu" typeface="Microsoft New Tai Lue"/>
+        <a:font script="Tfng" typeface="Ebrima"/>
+      </a:majorFont>
+      <a:minorFont>
+        <a:latin typeface="Aptos" panose="02110004020202020204"/>
+        <a:ea typeface=""/>
+        <a:cs typeface=""/>
+        <a:font script="Jpan" typeface="游ゴシック"/>
+        <a:font script="Hang" typeface="맑은 고딕"/>
+        <a:font script="Hans" typeface="等线"/>
+        <a:font script="Hant" typeface="新細明體"/>
+        <a:font script="Arab" typeface="Arial"/>
+        <a:font script="Hebr" typeface="Arial"/>
+        <a:font script="Thai" typeface="Cordia New"/>
+        <a:font script="Ethi" typeface="Nyala"/>
+        <a:font script="Beng" typeface="Vrinda"/>
+        <a:font script="Gujr" typeface="Shruti"/>
+        <a:font script="Khmr" typeface="DaunPenh"/>
+        <a:font script="Knda" typeface="Tunga"/>
+        <a:font script="Guru" typeface="Raavi"/>
+        <a:font script="Cans" typeface="Euphemia"/>
+        <a:font script="Cher" typeface="Plantagenet Cherokee"/>
+        <a:font script="Yiii" typeface="Microsoft Yi Baiti"/>
+        <a:font script="Tibt" typeface="Microsoft Himalaya"/>
+        <a:font script="Thaa" typeface="MV Boli"/>
+        <a:font script="Deva" typeface="Mangal"/>
+        <a:font script="Telu" typeface="Gautami"/>
+        <a:font script="Taml" typeface="Latha"/>
+        <a:font script="Syrc" typeface="Estrangelo Edessa"/>
+        <a:font script="Orya" typeface="Kalinga"/>
+        <a:font script="Mlym" typeface="Kartika"/>
+        <a:font script="Laoo" typeface="DokChampa"/>
+        <a:font script="Sinh" typeface="Iskoola Pota"/>
+        <a:font script="Mong" typeface="Mongolian Baiti"/>
+        <a:font script="Viet" typeface="Arial"/>
+        <a:font script="Uigh" typeface="Microsoft Uighur"/>
+        <a:font script="Geor" typeface="Sylfaen"/>
+        <a:font script="Armn" typeface="Arial"/>
+        <a:font script="Bugi" typeface="Leelawadee UI"/>
+        <a:font script="Bopo" typeface="Microsoft JhengHei"/>
+        <a:font script="Java" typeface="Javanese Text"/>
+        <a:font script="Lisu" typeface="Segoe UI"/>
+        <a:font script="Mymr" typeface="Myanmar Text"/>
+        <a:font script="Nkoo" typeface="Ebrima"/>
+        <a:font script="Olck" typeface="Nirmala UI"/>
+        <a:font script="Osma" typeface="Ebrima"/>
+        <a:font script="Phag" typeface="Phagspa"/>
+        <a:font script="Syrn" typeface="Estrangelo Edessa"/>
+        <a:font script="Syrj" typeface="Estrangelo Edessa"/>
+        <a:font script="Syre" typeface="Estrangelo Edessa"/>
+        <a:font script="Sora" typeface="Nirmala UI"/>
+        <a:font script="Tale" typeface="Microsoft Tai Le"/>
+        <a:font script="Talu" typeface="Microsoft New Tai Lue"/>
+        <a:font script="Tfng" typeface="Ebrima"/>
+      </a:minorFont>
+    </a:fontScheme>
+    <a:fmtScheme name="Office">
+      <a:fillStyleLst>
+        <a:solidFill>
+          <a:schemeClr val="phClr"/>
+        </a:solidFill>
+        <a:gradFill rotWithShape="1">
+          <a:gsLst>
+            <a:gs pos="0">
+              <a:schemeClr val="phClr">
+                <a:lumMod val="110000"/>
+                <a:satMod val="105000"/>
+                <a:tint val="67000"/>
+              </a:schemeClr>
+            </a:gs>
+            <a:gs pos="50000">
+              <a:schemeClr val="phClr">
+                <a:lumMod val="105000"/>
+                <a:satMod val="103000"/>
+                <a:tint val="73000"/>
+              </a:schemeClr>
+            </a:gs>
+            <a:gs pos="100000">
+              <a:schemeClr val="phClr">
+                <a:lumMod val="105000"/>
+                <a:satMod val="109000"/>
+                <a:tint val="81000"/>
+              </a:schemeClr>
+            </a:gs>
+          </a:gsLst>
+          <a:lin ang="5400000" scaled="0"/>
+        </a:gradFill>
+        <a:gradFill rotWithShape="1">
+          <a:gsLst>
+            <a:gs pos="0">
+              <a:schemeClr val="phClr">
+                <a:satMod val="103000"/>
+                <a:lumMod val="102000"/>
+                <a:tint val="94000"/>
+              </a:schemeClr>
+            </a:gs>
+            <a:gs pos="50000">
+              <a:schemeClr val="phClr">
+                <a:satMod val="110000"/>
+                <a:lumMod val="100000"/>
+                <a:shade val="100000"/>
+              </a:schemeClr>
+            </a:gs>
+            <a:gs pos="100000">
+              <a:schemeClr val="phClr">
+                <a:lumMod val="99000"/>
+                <a:satMod val="120000"/>
+                <a:shade val="78000"/>
+              </a:schemeClr>
+            </a:gs>
+          </a:gsLst>
+          <a:lin ang="5400000" scaled="0"/>
+        </a:gradFill>
+      </a:fillStyleLst>
+      <a:lnStyleLst>
+        <a:ln w="12700" cap="flat" cmpd="sng" algn="ctr">
+          <a:solidFill>
+            <a:schemeClr val="phClr"/>
+          </a:solidFill>
+          <a:prstDash val="solid"/>
+          <a:miter lim="800000"/>
+        </a:ln>
+        <a:ln w="19050" cap="flat" cmpd="sng" algn="ctr">
+          <a:solidFill>
+            <a:schemeClr val="phClr"/>
+          </a:solidFill>
+          <a:prstDash val="solid"/>
+          <a:miter lim="800000"/>
+        </a:ln>
+        <a:ln w="25400" cap="flat" cmpd="sng" algn="ctr">
+          <a:solidFill>
+            <a:schemeClr val="phClr"/>
+          </a:solidFill>
+          <a:prstDash val="solid"/>
+          <a:miter lim="800000"/>
+        </a:ln>
+      </a:lnStyleLst>
+      <a:effectStyleLst>
+        <a:effectStyle>
+          <a:effectLst/>
+        </a:effectStyle>
+        <a:effectStyle>
+          <a:effectLst/>
+        </a:effectStyle>
+        <a:effectStyle>
+          <a:effectLst>
+            <a:outerShdw blurRad="57150" dist="19050" dir="5400000" algn="ctr" rotWithShape="0">
+              <a:srgbClr val="000000">
+                <a:alpha val="63000"/>
+              </a:srgbClr>
+            </a:outerShdw>
+          </a:effectLst>
+        </a:effectStyle>
+      </a:effectStyleLst>
+      <a:bgFillStyleLst>
+        <a:solidFill>
+          <a:schemeClr val="phClr"/>
+        </a:solidFill>
+        <a:solidFill>
+          <a:schemeClr val="phClr">
+            <a:tint val="95000"/>
+            <a:satMod val="170000"/>
+          </a:schemeClr>
+        </a:solidFill>
+        <a:gradFill rotWithShape="1">
+          <a:gsLst>
+            <a:gs pos="0">
+              <a:schemeClr val="phClr">
+                <a:tint val="93000"/>
+                <a:satMod val="150000"/>
+                <a:shade val="98000"/>
+                <a:lumMod val="102000"/>
+              </a:schemeClr>
+            </a:gs>
+            <a:gs pos="50000">
+              <a:schemeClr val="phClr">
+                <a:tint val="98000"/>
+                <a:satMod val="130000"/>
+                <a:shade val="90000"/>
+                <a:lumMod val="103000"/>
+              </a:schemeClr>
+            </a:gs>
+            <a:gs pos="100000">
+              <a:schemeClr val="phClr">
+                <a:shade val="63000"/>
+                <a:satMod val="120000"/>
+              </a:schemeClr>
+            </a:gs>
+          </a:gsLst>
+          <a:lin ang="5400000" scaled="0"/>
+        </a:gradFill>
+      </a:bgFillStyleLst>
+    </a:fmtScheme>
+  </a:themeElements>
+  <a:objectDefaults>
+    <a:lnDef>
+      <a:spPr/>
+      <a:bodyPr/>
+      <a:lstStyle/>
+      <a:style>
+        <a:lnRef idx="2">
+          <a:schemeClr val="accent1"/>
+        </a:lnRef>
+        <a:fillRef idx="0">
+          <a:schemeClr val="accent1"/>
+        </a:fillRef>
+        <a:effectRef idx="1">
+          <a:schemeClr val="accent1"/>
+        </a:effectRef>
+        <a:fontRef idx="minor">
+          <a:schemeClr val="tx1"/>
+        </a:fontRef>
+      </a:style>
+    </a:lnDef>
+  </a:objectDefaults>
+  <a:extraClrSchemeLst/>
+  <a:extLst>
+    <a:ext uri="{05A4C25C-085E-4340-85A3-A5531E510DB2}">
+      <thm15:themeFamily xmlns:thm15="http://schemas.microsoft.com/office/thememl/2012/main" name="Office Theme" id="{2E142A2C-CD16-42D6-873A-C26D2A0506FA}" vid="{1BDDFF52-6CD6-40A5-AB3C-68EB2F1E4D0A}"/>
+    </a:ext>
+  </a:extLst>
+</a:theme>
+</file>
+
+<file path=docMetadata/LabelInfo.xml><?xml version="1.0" encoding="utf-8"?>
+<clbl:labelList xmlns:clbl="http://schemas.microsoft.com/office/2020/mipLabelMetadata">
+  <clbl:label id="{f42aa342-8706-4288-bd11-ebb85995028c}" enabled="1" method="Standard" siteId="{72f988bf-86f1-41af-91ab-2d7cd011db47}" contentBits="0" removed="0"/>
+</clbl:labelList>
 </file>
</xml_diff>